<commit_message>
chore: finalize pipeline, atomic staging, dynamic validation and presentation updates for defense
</commit_message>
<xml_diff>
--- a/Mahmoud_Amin_3_presentation_102026.pptx
+++ b/Mahmoud_Amin_3_presentation_102026.pptx
@@ -2527,7 +2527,37 @@
                 <a:ea typeface="Calibri" pitchFamily="34" charset="-122"/>
                 <a:cs typeface="Calibri" pitchFamily="34" charset="-120"/>
               </a:rPr>
-              <a:t>nettoyage → réconciliation → chiffre d'affaires → Z-score des vins millésimes</a:t>
+              <a:t>nettoyage → réconciliation → chiffre d'affaires → Z-score des </a:t>
+            </a:r>
+            <a:r>
+              <a:rPr lang="en-US" sz="1400" dirty="0" err="1">
+                <a:solidFill>
+                  <a:schemeClr val="tx1"/>
+                </a:solidFill>
+                <a:latin typeface="Calibri" pitchFamily="34" charset="0"/>
+                <a:ea typeface="Calibri" pitchFamily="34" charset="-122"/>
+                <a:cs typeface="Calibri" pitchFamily="34" charset="-120"/>
+              </a:rPr>
+              <a:t>vins</a:t>
+            </a:r>
+            <a:r>
+              <a:rPr lang="en-US" sz="1400" dirty="0">
+                <a:solidFill>
+                  <a:schemeClr val="tx1"/>
+                </a:solidFill>
+                <a:latin typeface="Calibri" pitchFamily="34" charset="0"/>
+                <a:ea typeface="Calibri" pitchFamily="34" charset="-122"/>
+                <a:cs typeface="Calibri" pitchFamily="34" charset="-120"/>
+              </a:rPr>
+              <a:t> </a:t>
+            </a:r>
+            <a:r>
+              <a:rPr lang="en-US" sz="1400" dirty="0">
+                <a:latin typeface="Calibri" pitchFamily="34" charset="0"/>
+                <a:ea typeface="Calibri" pitchFamily="34" charset="-122"/>
+                <a:cs typeface="Calibri" pitchFamily="34" charset="-120"/>
+              </a:rPr>
+              <a:t>premium</a:t>
             </a:r>
             <a:endParaRPr lang="en-US" sz="1400" dirty="0"/>
           </a:p>
@@ -2770,6 +2800,17 @@
               <a:t>Laure (B2B) : </a:t>
             </a:r>
             <a:r>
+              <a:rPr lang="en-US" sz="1400" dirty="0" err="1">
+                <a:solidFill>
+                  <a:schemeClr val="tx1"/>
+                </a:solidFill>
+                <a:latin typeface="Calibri" pitchFamily="34" charset="0"/>
+                <a:ea typeface="Calibri" pitchFamily="34" charset="-122"/>
+                <a:cs typeface="Calibri" pitchFamily="34" charset="-120"/>
+              </a:rPr>
+              <a:t>vins</a:t>
+            </a:r>
+            <a:r>
               <a:rPr lang="en-US" sz="1400" dirty="0">
                 <a:solidFill>
                   <a:schemeClr val="tx1"/>
@@ -2778,7 +2819,7 @@
                 <a:ea typeface="Calibri" pitchFamily="34" charset="-122"/>
                 <a:cs typeface="Calibri" pitchFamily="34" charset="-120"/>
               </a:rPr>
-              <a:t>vins millésimes / premium en CSV</a:t>
+              <a:t> premium en CSV</a:t>
             </a:r>
             <a:endParaRPr lang="en-US" sz="1400" dirty="0"/>
           </a:p>
@@ -9264,7 +9305,7 @@
         <p:spPr>
           <a:xfrm>
             <a:off x="5715000" y="2194560"/>
-            <a:ext cx="2971800" cy="1097280"/>
+            <a:ext cx="2971800" cy="1188720"/>
           </a:xfrm>
           <a:prstGeom prst="roundRect">
             <a:avLst>
@@ -9390,7 +9431,7 @@
         <p:spPr>
           <a:xfrm>
             <a:off x="5852160" y="2788920"/>
-            <a:ext cx="2697480" cy="457200"/>
+            <a:ext cx="2834640" cy="457200"/>
           </a:xfrm>
           <a:prstGeom prst="rect">
             <a:avLst/>
@@ -9414,7 +9455,98 @@
                 <a:ea typeface="Calibri" pitchFamily="34" charset="-122"/>
                 <a:cs typeface="Calibri" pitchFamily="34" charset="-120"/>
               </a:rPr>
-              <a:t>Les tâches aval (calculs, exports Excel/CSV) ne sont pas exécutées.</a:t>
+              <a:t>Les tâches aval (calculs, exports Excel/CSV) ne sont pas </a:t>
+            </a:r>
+            <a:r>
+              <a:rPr lang="en-US" sz="1100" dirty="0" err="1">
+                <a:solidFill>
+                  <a:schemeClr val="tx1"/>
+                </a:solidFill>
+                <a:latin typeface="Calibri" pitchFamily="34" charset="0"/>
+                <a:ea typeface="Calibri" pitchFamily="34" charset="-122"/>
+                <a:cs typeface="Calibri" pitchFamily="34" charset="-120"/>
+              </a:rPr>
+              <a:t>exécutées</a:t>
+            </a:r>
+            <a:r>
+              <a:rPr lang="en-US" sz="1100" dirty="0">
+                <a:solidFill>
+                  <a:schemeClr val="tx1"/>
+                </a:solidFill>
+                <a:latin typeface="Calibri" pitchFamily="34" charset="0"/>
+                <a:ea typeface="Calibri" pitchFamily="34" charset="-122"/>
+                <a:cs typeface="Calibri" pitchFamily="34" charset="-120"/>
+              </a:rPr>
+              <a:t>.</a:t>
+            </a:r>
+          </a:p>
+          <a:p>
+            <a:pPr marL="0" indent="0">
+              <a:buNone/>
+            </a:pPr>
+            <a:r>
+              <a:rPr lang="en-US" sz="1100" dirty="0">
+                <a:latin typeface="Calibri" pitchFamily="34" charset="0"/>
+                <a:ea typeface="Calibri" pitchFamily="34" charset="-122"/>
+                <a:cs typeface="Calibri" pitchFamily="34" charset="-120"/>
+              </a:rPr>
+              <a:t>Les </a:t>
+            </a:r>
+            <a:r>
+              <a:rPr lang="en-US" sz="1100" dirty="0" err="1">
+                <a:latin typeface="Calibri" pitchFamily="34" charset="0"/>
+                <a:ea typeface="Calibri" pitchFamily="34" charset="-122"/>
+                <a:cs typeface="Calibri" pitchFamily="34" charset="-120"/>
+              </a:rPr>
+              <a:t>anciens</a:t>
+            </a:r>
+            <a:r>
+              <a:rPr lang="en-US" sz="1100" dirty="0">
+                <a:latin typeface="Calibri" pitchFamily="34" charset="0"/>
+                <a:ea typeface="Calibri" pitchFamily="34" charset="-122"/>
+                <a:cs typeface="Calibri" pitchFamily="34" charset="-120"/>
+              </a:rPr>
+              <a:t> </a:t>
+            </a:r>
+            <a:r>
+              <a:rPr lang="en-US" sz="1100" dirty="0" err="1">
+                <a:latin typeface="Calibri" pitchFamily="34" charset="0"/>
+                <a:ea typeface="Calibri" pitchFamily="34" charset="-122"/>
+                <a:cs typeface="Calibri" pitchFamily="34" charset="-120"/>
+              </a:rPr>
+              <a:t>fichiers</a:t>
+            </a:r>
+            <a:r>
+              <a:rPr lang="en-US" sz="1100" dirty="0">
+                <a:latin typeface="Calibri" pitchFamily="34" charset="0"/>
+                <a:ea typeface="Calibri" pitchFamily="34" charset="-122"/>
+                <a:cs typeface="Calibri" pitchFamily="34" charset="-120"/>
+              </a:rPr>
+              <a:t> de production </a:t>
+            </a:r>
+            <a:r>
+              <a:rPr lang="en-US" sz="1100" dirty="0" err="1">
+                <a:latin typeface="Calibri" pitchFamily="34" charset="0"/>
+                <a:ea typeface="Calibri" pitchFamily="34" charset="-122"/>
+                <a:cs typeface="Calibri" pitchFamily="34" charset="-120"/>
+              </a:rPr>
+              <a:t>sont</a:t>
+            </a:r>
+            <a:r>
+              <a:rPr lang="en-US" sz="1100" dirty="0">
+                <a:latin typeface="Calibri" pitchFamily="34" charset="0"/>
+                <a:ea typeface="Calibri" pitchFamily="34" charset="-122"/>
+                <a:cs typeface="Calibri" pitchFamily="34" charset="-120"/>
+              </a:rPr>
+              <a:t> </a:t>
+            </a:r>
+            <a:r>
+              <a:rPr lang="en-US" sz="1100" dirty="0" err="1">
+                <a:latin typeface="Calibri" pitchFamily="34" charset="0"/>
+                <a:ea typeface="Calibri" pitchFamily="34" charset="-122"/>
+                <a:cs typeface="Calibri" pitchFamily="34" charset="-120"/>
+              </a:rPr>
+              <a:t>préservés</a:t>
             </a:r>
             <a:endParaRPr lang="en-US" sz="1100" dirty="0"/>
           </a:p>
@@ -9428,7 +9560,7 @@
         </p:nvSpPr>
         <p:spPr>
           <a:xfrm>
-            <a:off x="5715000" y="3429000"/>
+            <a:off x="5715000" y="3546986"/>
             <a:ext cx="2971800" cy="1097280"/>
           </a:xfrm>
           <a:prstGeom prst="roundRect">
@@ -9464,7 +9596,7 @@
         </p:nvSpPr>
         <p:spPr>
           <a:xfrm>
-            <a:off x="5852160" y="3566160"/>
+            <a:off x="5852160" y="3684146"/>
             <a:ext cx="411480" cy="411480"/>
           </a:xfrm>
           <a:prstGeom prst="ellipse">
@@ -9499,7 +9631,7 @@
         </p:blipFill>
         <p:spPr>
           <a:xfrm>
-            <a:off x="5955030" y="3669030"/>
+            <a:off x="5955030" y="3787016"/>
             <a:ext cx="205740" cy="205740"/>
           </a:xfrm>
           <a:prstGeom prst="rect">
@@ -9515,7 +9647,7 @@
         </p:nvSpPr>
         <p:spPr>
           <a:xfrm>
-            <a:off x="6355080" y="3538728"/>
+            <a:off x="6355080" y="3656714"/>
             <a:ext cx="2240280" cy="457200"/>
           </a:xfrm>
           <a:prstGeom prst="rect">
@@ -9554,7 +9686,7 @@
         </p:nvSpPr>
         <p:spPr>
           <a:xfrm>
-            <a:off x="5806765" y="4023360"/>
+            <a:off x="5806765" y="4141346"/>
             <a:ext cx="2915704" cy="457200"/>
           </a:xfrm>
           <a:prstGeom prst="rect">
@@ -9920,7 +10052,26 @@
                 <a:ea typeface="Calibri" pitchFamily="34" charset="-122"/>
                 <a:cs typeface="Calibri" pitchFamily="34" charset="-120"/>
               </a:rPr>
-              <a:t>Retry automatique : 3 tentatives espacées de 15 secondes avant échec.</a:t>
+              <a:t>Retry automatique : 3 tentatives espacées de </a:t>
+            </a:r>
+            <a:r>
+              <a:rPr lang="en-US" sz="1200" dirty="0">
+                <a:latin typeface="Calibri" pitchFamily="34" charset="0"/>
+                <a:ea typeface="Calibri" pitchFamily="34" charset="-122"/>
+                <a:cs typeface="Calibri" pitchFamily="34" charset="-120"/>
+              </a:rPr>
+              <a:t>10</a:t>
+            </a:r>
+            <a:r>
+              <a:rPr lang="en-US" sz="1200" dirty="0">
+                <a:solidFill>
+                  <a:schemeClr val="tx1"/>
+                </a:solidFill>
+                <a:latin typeface="Calibri" pitchFamily="34" charset="0"/>
+                <a:ea typeface="Calibri" pitchFamily="34" charset="-122"/>
+                <a:cs typeface="Calibri" pitchFamily="34" charset="-120"/>
+              </a:rPr>
+              <a:t> secondes avant échec.</a:t>
             </a:r>
             <a:endParaRPr lang="en-US" sz="1300" dirty="0"/>
           </a:p>

</xml_diff>

<commit_message>
Finalisation P10 : calculs séquencés, exports parallèles, Test 5, pointeur LAST_VALID_LOT et MAJ doc/PPT
</commit_message>
<xml_diff>
--- a/Mahmoud_Amin_3_presentation_102026.pptx
+++ b/Mahmoud_Amin_3_presentation_102026.pptx
@@ -2549,15 +2549,7 @@
                 <a:ea typeface="Calibri" pitchFamily="34" charset="-122"/>
                 <a:cs typeface="Calibri" pitchFamily="34" charset="-120"/>
               </a:rPr>
-              <a:t> </a:t>
-            </a:r>
-            <a:r>
-              <a:rPr lang="en-US" sz="1400" dirty="0">
-                <a:latin typeface="Calibri" pitchFamily="34" charset="0"/>
-                <a:ea typeface="Calibri" pitchFamily="34" charset="-122"/>
-                <a:cs typeface="Calibri" pitchFamily="34" charset="-120"/>
-              </a:rPr>
-              <a:t>premium</a:t>
+              <a:t> premium</a:t>
             </a:r>
             <a:endParaRPr lang="en-US" sz="1400" dirty="0"/>
           </a:p>
@@ -3070,7 +3062,29 @@
                 <a:ea typeface="Calibri" pitchFamily="34" charset="-122"/>
                 <a:cs typeface="Calibri" pitchFamily="34" charset="-120"/>
               </a:rPr>
-              <a:t>le 15 de chaque mois à 09h00, sans intervention humaine</a:t>
+              <a:t>le 15 de chaque mois à 09h00 (</a:t>
+            </a:r>
+            <a:r>
+              <a:rPr lang="en-US" sz="1400" dirty="0" err="1">
+                <a:solidFill>
+                  <a:schemeClr val="tx1"/>
+                </a:solidFill>
+                <a:latin typeface="Calibri" pitchFamily="34" charset="0"/>
+                <a:ea typeface="Calibri" pitchFamily="34" charset="-122"/>
+                <a:cs typeface="Calibri" pitchFamily="34" charset="-120"/>
+              </a:rPr>
+              <a:t>heure</a:t>
+            </a:r>
+            <a:r>
+              <a:rPr lang="en-US" sz="1400" dirty="0">
+                <a:solidFill>
+                  <a:schemeClr val="tx1"/>
+                </a:solidFill>
+                <a:latin typeface="Calibri" pitchFamily="34" charset="0"/>
+                <a:ea typeface="Calibri" pitchFamily="34" charset="-122"/>
+                <a:cs typeface="Calibri" pitchFamily="34" charset="-120"/>
+              </a:rPr>
+              <a:t> de Paris), sans intervention humaine</a:t>
             </a:r>
             <a:endParaRPr lang="en-US" sz="1400" dirty="0"/>
           </a:p>
@@ -3479,7 +3493,95 @@
                 <a:ea typeface="Calibri" pitchFamily="34" charset="-122"/>
                 <a:cs typeface="Calibri" pitchFamily="34" charset="-120"/>
               </a:rPr>
-              <a:t>Choix validé avec la DSI : interface visuelle, code déclaratif (YAML), branches parallèles, planification Cron, gestion centralisée des erreurs.</a:t>
+              <a:t>Choix validé avec la DSI : interface visuelle, code déclaratif (YAML), </a:t>
+            </a:r>
+            <a:r>
+              <a:rPr lang="en-US" sz="1200" dirty="0" err="1">
+                <a:solidFill>
+                  <a:schemeClr val="tx1"/>
+                </a:solidFill>
+                <a:latin typeface="Calibri" pitchFamily="34" charset="0"/>
+                <a:ea typeface="Calibri" pitchFamily="34" charset="-122"/>
+                <a:cs typeface="Calibri" pitchFamily="34" charset="-120"/>
+              </a:rPr>
+              <a:t>calcul</a:t>
+            </a:r>
+            <a:r>
+              <a:rPr lang="en-US" sz="1200" dirty="0">
+                <a:solidFill>
+                  <a:schemeClr val="tx1"/>
+                </a:solidFill>
+                <a:latin typeface="Calibri" pitchFamily="34" charset="0"/>
+                <a:ea typeface="Calibri" pitchFamily="34" charset="-122"/>
+                <a:cs typeface="Calibri" pitchFamily="34" charset="-120"/>
+              </a:rPr>
+              <a:t> </a:t>
+            </a:r>
+            <a:r>
+              <a:rPr lang="en-US" sz="1200" dirty="0" err="1">
+                <a:solidFill>
+                  <a:schemeClr val="tx1"/>
+                </a:solidFill>
+                <a:latin typeface="Calibri" pitchFamily="34" charset="0"/>
+                <a:ea typeface="Calibri" pitchFamily="34" charset="-122"/>
+                <a:cs typeface="Calibri" pitchFamily="34" charset="-120"/>
+              </a:rPr>
+              <a:t>séquencés</a:t>
+            </a:r>
+            <a:r>
+              <a:rPr lang="en-US" sz="1200" dirty="0">
+                <a:solidFill>
+                  <a:schemeClr val="tx1"/>
+                </a:solidFill>
+                <a:latin typeface="Calibri" pitchFamily="34" charset="0"/>
+                <a:ea typeface="Calibri" pitchFamily="34" charset="-122"/>
+                <a:cs typeface="Calibri" pitchFamily="34" charset="-120"/>
+              </a:rPr>
+              <a:t> et exports parallèles, planification Cron, </a:t>
+            </a:r>
+            <a:r>
+              <a:rPr lang="en-US" sz="1200" dirty="0" err="1">
+                <a:solidFill>
+                  <a:schemeClr val="tx1"/>
+                </a:solidFill>
+                <a:latin typeface="Calibri" pitchFamily="34" charset="0"/>
+                <a:ea typeface="Calibri" pitchFamily="34" charset="-122"/>
+                <a:cs typeface="Calibri" pitchFamily="34" charset="-120"/>
+              </a:rPr>
+              <a:t>alerte</a:t>
+            </a:r>
+            <a:r>
+              <a:rPr lang="en-US" sz="1200" dirty="0">
+                <a:solidFill>
+                  <a:schemeClr val="tx1"/>
+                </a:solidFill>
+                <a:latin typeface="Calibri" pitchFamily="34" charset="0"/>
+                <a:ea typeface="Calibri" pitchFamily="34" charset="-122"/>
+                <a:cs typeface="Calibri" pitchFamily="34" charset="-120"/>
+              </a:rPr>
+              <a:t> </a:t>
+            </a:r>
+            <a:r>
+              <a:rPr lang="en-US" sz="1200" dirty="0" err="1">
+                <a:solidFill>
+                  <a:schemeClr val="tx1"/>
+                </a:solidFill>
+                <a:latin typeface="Calibri" pitchFamily="34" charset="0"/>
+                <a:ea typeface="Calibri" pitchFamily="34" charset="-122"/>
+                <a:cs typeface="Calibri" pitchFamily="34" charset="-120"/>
+              </a:rPr>
+              <a:t>tracée</a:t>
+            </a:r>
+            <a:r>
+              <a:rPr lang="en-US" sz="1200" dirty="0">
+                <a:solidFill>
+                  <a:schemeClr val="tx1"/>
+                </a:solidFill>
+                <a:latin typeface="Calibri" pitchFamily="34" charset="0"/>
+                <a:ea typeface="Calibri" pitchFamily="34" charset="-122"/>
+                <a:cs typeface="Calibri" pitchFamily="34" charset="-120"/>
+              </a:rPr>
+              <a:t> dans les logs.</a:t>
             </a:r>
             <a:endParaRPr lang="en-US" sz="1200" dirty="0"/>
           </a:p>
@@ -3661,7 +3763,7 @@
                 <a:ea typeface="Calibri" pitchFamily="34" charset="-122"/>
                 <a:cs typeface="Calibri" pitchFamily="34" charset="-120"/>
               </a:rPr>
-              <a:t>Base embarquée ultra-rapide (un seul fichier bottleneck.duckdb). Nettoyage, </a:t>
+              <a:t>Base embarquée ultra-</a:t>
             </a:r>
             <a:r>
               <a:rPr lang="en-US" sz="1200" dirty="0" err="1">
@@ -3672,7 +3774,7 @@
                 <a:ea typeface="Calibri" pitchFamily="34" charset="-122"/>
                 <a:cs typeface="Calibri" pitchFamily="34" charset="-120"/>
               </a:rPr>
-              <a:t>dédoublonnage</a:t>
+              <a:t>rapide</a:t>
             </a:r>
             <a:r>
               <a:rPr lang="en-US" sz="1200" dirty="0">
@@ -3683,7 +3785,205 @@
                 <a:ea typeface="Calibri" pitchFamily="34" charset="-122"/>
                 <a:cs typeface="Calibri" pitchFamily="34" charset="-120"/>
               </a:rPr>
-              <a:t> et jointures sans serveur lourd.</a:t>
+              <a:t> (</a:t>
+            </a:r>
+            <a:r>
+              <a:rPr lang="en-US" sz="1200" dirty="0" err="1">
+                <a:solidFill>
+                  <a:schemeClr val="tx1"/>
+                </a:solidFill>
+                <a:latin typeface="Calibri" pitchFamily="34" charset="0"/>
+                <a:ea typeface="Calibri" pitchFamily="34" charset="-122"/>
+                <a:cs typeface="Calibri" pitchFamily="34" charset="-120"/>
+              </a:rPr>
+              <a:t>bottleneck.duckdb</a:t>
+            </a:r>
+            <a:r>
+              <a:rPr lang="en-US" sz="1200" dirty="0">
+                <a:solidFill>
+                  <a:schemeClr val="tx1"/>
+                </a:solidFill>
+                <a:latin typeface="Calibri" pitchFamily="34" charset="0"/>
+                <a:ea typeface="Calibri" pitchFamily="34" charset="-122"/>
+                <a:cs typeface="Calibri" pitchFamily="34" charset="-120"/>
+              </a:rPr>
+              <a:t>). </a:t>
+            </a:r>
+            <a:r>
+              <a:rPr lang="en-US" sz="1200" dirty="0" err="1">
+                <a:solidFill>
+                  <a:schemeClr val="tx1"/>
+                </a:solidFill>
+                <a:latin typeface="Calibri" pitchFamily="34" charset="0"/>
+                <a:ea typeface="Calibri" pitchFamily="34" charset="-122"/>
+                <a:cs typeface="Calibri" pitchFamily="34" charset="-120"/>
+              </a:rPr>
+              <a:t>Traitements</a:t>
+            </a:r>
+            <a:r>
+              <a:rPr lang="en-US" sz="1200" dirty="0">
+                <a:solidFill>
+                  <a:schemeClr val="tx1"/>
+                </a:solidFill>
+                <a:latin typeface="Calibri" pitchFamily="34" charset="0"/>
+                <a:ea typeface="Calibri" pitchFamily="34" charset="-122"/>
+                <a:cs typeface="Calibri" pitchFamily="34" charset="-120"/>
+              </a:rPr>
+              <a:t> SQL </a:t>
+            </a:r>
+            <a:r>
+              <a:rPr lang="en-US" sz="1200" dirty="0" err="1">
+                <a:solidFill>
+                  <a:schemeClr val="tx1"/>
+                </a:solidFill>
+                <a:latin typeface="Calibri" pitchFamily="34" charset="0"/>
+                <a:ea typeface="Calibri" pitchFamily="34" charset="-122"/>
+                <a:cs typeface="Calibri" pitchFamily="34" charset="-120"/>
+              </a:rPr>
+              <a:t>séquencés</a:t>
+            </a:r>
+            <a:r>
+              <a:rPr lang="en-US" sz="1200" dirty="0">
+                <a:solidFill>
+                  <a:schemeClr val="tx1"/>
+                </a:solidFill>
+                <a:latin typeface="Calibri" pitchFamily="34" charset="0"/>
+                <a:ea typeface="Calibri" pitchFamily="34" charset="-122"/>
+                <a:cs typeface="Calibri" pitchFamily="34" charset="-120"/>
+              </a:rPr>
+              <a:t> (</a:t>
+            </a:r>
+            <a:r>
+              <a:rPr lang="en-US" sz="1200" dirty="0" err="1">
+                <a:solidFill>
+                  <a:schemeClr val="tx1"/>
+                </a:solidFill>
+                <a:latin typeface="Calibri" pitchFamily="34" charset="0"/>
+                <a:ea typeface="Calibri" pitchFamily="34" charset="-122"/>
+                <a:cs typeface="Calibri" pitchFamily="34" charset="-120"/>
+              </a:rPr>
+              <a:t>verrou</a:t>
+            </a:r>
+            <a:r>
+              <a:rPr lang="en-US" sz="1200" dirty="0">
+                <a:solidFill>
+                  <a:schemeClr val="tx1"/>
+                </a:solidFill>
+                <a:latin typeface="Calibri" pitchFamily="34" charset="0"/>
+                <a:ea typeface="Calibri" pitchFamily="34" charset="-122"/>
+                <a:cs typeface="Calibri" pitchFamily="34" charset="-120"/>
+              </a:rPr>
+              <a:t> </a:t>
+            </a:r>
+            <a:r>
+              <a:rPr lang="en-US" sz="1200" dirty="0" err="1">
+                <a:solidFill>
+                  <a:schemeClr val="tx1"/>
+                </a:solidFill>
+                <a:latin typeface="Calibri" pitchFamily="34" charset="0"/>
+                <a:ea typeface="Calibri" pitchFamily="34" charset="-122"/>
+                <a:cs typeface="Calibri" pitchFamily="34" charset="-120"/>
+              </a:rPr>
+              <a:t>d’écriture</a:t>
+            </a:r>
+            <a:r>
+              <a:rPr lang="en-US" sz="1200" dirty="0">
+                <a:solidFill>
+                  <a:schemeClr val="tx1"/>
+                </a:solidFill>
+                <a:latin typeface="Calibri" pitchFamily="34" charset="0"/>
+                <a:ea typeface="Calibri" pitchFamily="34" charset="-122"/>
+                <a:cs typeface="Calibri" pitchFamily="34" charset="-120"/>
+              </a:rPr>
+              <a:t> unique) </a:t>
+            </a:r>
+            <a:r>
+              <a:rPr lang="en-US" sz="1200" dirty="0" err="1">
+                <a:solidFill>
+                  <a:schemeClr val="tx1"/>
+                </a:solidFill>
+                <a:latin typeface="Calibri" pitchFamily="34" charset="0"/>
+                <a:ea typeface="Calibri" pitchFamily="34" charset="-122"/>
+                <a:cs typeface="Calibri" pitchFamily="34" charset="-120"/>
+              </a:rPr>
+              <a:t>en</a:t>
+            </a:r>
+            <a:r>
+              <a:rPr lang="en-US" sz="1200" dirty="0">
+                <a:solidFill>
+                  <a:schemeClr val="tx1"/>
+                </a:solidFill>
+                <a:latin typeface="Calibri" pitchFamily="34" charset="0"/>
+                <a:ea typeface="Calibri" pitchFamily="34" charset="-122"/>
+                <a:cs typeface="Calibri" pitchFamily="34" charset="-120"/>
+              </a:rPr>
+              <a:t> staging </a:t>
+            </a:r>
+            <a:r>
+              <a:rPr lang="en-US" sz="1200" dirty="0" err="1">
+                <a:solidFill>
+                  <a:schemeClr val="tx1"/>
+                </a:solidFill>
+                <a:latin typeface="Calibri" pitchFamily="34" charset="0"/>
+                <a:ea typeface="Calibri" pitchFamily="34" charset="-122"/>
+                <a:cs typeface="Calibri" pitchFamily="34" charset="-120"/>
+              </a:rPr>
+              <a:t>isolé</a:t>
+            </a:r>
+            <a:r>
+              <a:rPr lang="en-US" sz="1200" dirty="0">
+                <a:solidFill>
+                  <a:schemeClr val="tx1"/>
+                </a:solidFill>
+                <a:latin typeface="Calibri" pitchFamily="34" charset="0"/>
+                <a:ea typeface="Calibri" pitchFamily="34" charset="-122"/>
+                <a:cs typeface="Calibri" pitchFamily="34" charset="-120"/>
+              </a:rPr>
+              <a:t>, </a:t>
+            </a:r>
+            <a:r>
+              <a:rPr lang="en-US" sz="1200" dirty="0" err="1">
+                <a:solidFill>
+                  <a:schemeClr val="tx1"/>
+                </a:solidFill>
+                <a:latin typeface="Calibri" pitchFamily="34" charset="0"/>
+                <a:ea typeface="Calibri" pitchFamily="34" charset="-122"/>
+                <a:cs typeface="Calibri" pitchFamily="34" charset="-120"/>
+              </a:rPr>
+              <a:t>puis</a:t>
+            </a:r>
+            <a:r>
+              <a:rPr lang="en-US" sz="1200" dirty="0">
+                <a:solidFill>
+                  <a:schemeClr val="tx1"/>
+                </a:solidFill>
+                <a:latin typeface="Calibri" pitchFamily="34" charset="0"/>
+                <a:ea typeface="Calibri" pitchFamily="34" charset="-122"/>
+                <a:cs typeface="Calibri" pitchFamily="34" charset="-120"/>
+              </a:rPr>
+              <a:t> lectures </a:t>
+            </a:r>
+            <a:r>
+              <a:rPr lang="en-US" sz="1200" dirty="0" err="1">
+                <a:solidFill>
+                  <a:schemeClr val="tx1"/>
+                </a:solidFill>
+                <a:latin typeface="Calibri" pitchFamily="34" charset="0"/>
+                <a:ea typeface="Calibri" pitchFamily="34" charset="-122"/>
+                <a:cs typeface="Calibri" pitchFamily="34" charset="-120"/>
+              </a:rPr>
+              <a:t>paralléles</a:t>
+            </a:r>
+            <a:r>
+              <a:rPr lang="en-US" sz="1200" dirty="0">
+                <a:solidFill>
+                  <a:schemeClr val="tx1"/>
+                </a:solidFill>
+                <a:latin typeface="Calibri" pitchFamily="34" charset="0"/>
+                <a:ea typeface="Calibri" pitchFamily="34" charset="-122"/>
+                <a:cs typeface="Calibri" pitchFamily="34" charset="-120"/>
+              </a:rPr>
+              <a:t>.</a:t>
             </a:r>
             <a:endParaRPr lang="en-US" sz="1200" dirty="0"/>
           </a:p>
@@ -4138,7 +4438,7 @@
         </p:nvSpPr>
         <p:spPr>
           <a:xfrm>
-            <a:off x="457200" y="201168"/>
+            <a:off x="457200" y="162940"/>
             <a:ext cx="8229600" cy="640080"/>
           </a:xfrm>
           <a:prstGeom prst="rect">
@@ -4171,17 +4471,19 @@
       </p:sp>
       <p:sp>
         <p:nvSpPr>
-          <p:cNvPr id="3" name="Cadre schéma"/>
+          <p:cNvPr id="5" name="Point clé 1"/>
           <p:cNvSpPr/>
           <p:nvPr/>
         </p:nvSpPr>
         <p:spPr>
           <a:xfrm>
-            <a:off x="1097280" y="868680"/>
-            <a:ext cx="6949440" cy="3407792"/>
-          </a:xfrm>
-          <a:prstGeom prst="rect">
-            <a:avLst/>
+            <a:off x="457200" y="4492060"/>
+            <a:ext cx="4023360" cy="564571"/>
+          </a:xfrm>
+          <a:prstGeom prst="roundRect">
+            <a:avLst>
+              <a:gd name="adj" fmla="val 11765"/>
+            </a:avLst>
           </a:prstGeom>
           <a:solidFill>
             <a:schemeClr val="bg1"/>
@@ -4203,9 +4505,36 @@
           </a:p>
         </p:txBody>
       </p:sp>
+      <p:sp>
+        <p:nvSpPr>
+          <p:cNvPr id="6" name="Icône point 1 cercle"/>
+          <p:cNvSpPr/>
+          <p:nvPr/>
+        </p:nvSpPr>
+        <p:spPr>
+          <a:xfrm>
+            <a:off x="548640" y="4542776"/>
+            <a:ext cx="402336" cy="402336"/>
+          </a:xfrm>
+          <a:prstGeom prst="ellipse">
+            <a:avLst/>
+          </a:prstGeom>
+          <a:solidFill>
+            <a:schemeClr val="accent1"/>
+          </a:solidFill>
+          <a:ln/>
+        </p:spPr>
+        <p:txBody>
+          <a:bodyPr/>
+          <a:lstStyle/>
+          <a:p>
+            <a:endParaRPr lang="fr-FR"/>
+          </a:p>
+        </p:txBody>
+      </p:sp>
       <p:pic>
         <p:nvPicPr>
-          <p:cNvPr id="4" name="Logigramme" descr="Logigramme fonctionnel du pipeline BottleNeck"/>
+          <p:cNvPr id="7" name="Icône point 1" descr="Icône point 1"/>
           <p:cNvPicPr>
             <a:picLocks noChangeAspect="1"/>
           </p:cNvPicPr>
@@ -4219,8 +4548,8 @@
         </p:blipFill>
         <p:spPr>
           <a:xfrm>
-            <a:off x="1143000" y="914400"/>
-            <a:ext cx="6858000" cy="3316352"/>
+            <a:off x="649224" y="4643360"/>
+            <a:ext cx="201168" cy="201168"/>
           </a:xfrm>
           <a:prstGeom prst="rect">
             <a:avLst/>
@@ -4229,14 +4558,58 @@
       </p:pic>
       <p:sp>
         <p:nvSpPr>
-          <p:cNvPr id="5" name="Point clé 1"/>
+          <p:cNvPr id="8" name="Text 4"/>
+          <p:cNvSpPr txBox="1"/>
+          <p:nvPr/>
+        </p:nvSpPr>
+        <p:spPr>
+          <a:xfrm>
+            <a:off x="1051560" y="4497902"/>
+            <a:ext cx="3337560" cy="548640"/>
+          </a:xfrm>
+          <a:prstGeom prst="rect">
+            <a:avLst/>
+          </a:prstGeom>
+          <a:noFill/>
+          <a:ln/>
+        </p:spPr>
+        <p:txBody>
+          <a:bodyPr wrap="square" lIns="0" tIns="0" rIns="0" bIns="0" rtlCol="0" anchor="ctr"/>
+          <a:lstStyle/>
+          <a:p>
+            <a:r>
+              <a:rPr lang="fr-FR" sz="1100" b="1" dirty="0"/>
+              <a:t>Calculs séquencés puis exports parallèles </a:t>
+            </a:r>
+            <a:r>
+              <a:rPr lang="fr-FR" sz="1100" dirty="0"/>
+              <a:t>: Étapes 1 à 4B l'une après l'autre → Étape 5 (exports Excel &amp; CSV en parallèle) → Étape 6 (lot indiqué par LAST_VALID_LOT.txt)</a:t>
+            </a:r>
+            <a:r>
+              <a:rPr lang="en-US" sz="1100" dirty="0">
+                <a:solidFill>
+                  <a:schemeClr val="tx1"/>
+                </a:solidFill>
+                <a:latin typeface="Calibri" pitchFamily="34" charset="0"/>
+                <a:ea typeface="Calibri" pitchFamily="34" charset="-122"/>
+                <a:cs typeface="Calibri" pitchFamily="34" charset="-120"/>
+              </a:rPr>
+              <a:t>)</a:t>
+            </a:r>
+            <a:endParaRPr lang="en-US" sz="1100" dirty="0"/>
+          </a:p>
+        </p:txBody>
+      </p:sp>
+      <p:sp>
+        <p:nvSpPr>
+          <p:cNvPr id="9" name="Point clé 2"/>
           <p:cNvSpPr/>
           <p:nvPr/>
         </p:nvSpPr>
         <p:spPr>
           <a:xfrm>
-            <a:off x="457200" y="4395344"/>
-            <a:ext cx="4023360" cy="621792"/>
+            <a:off x="4572000" y="4492060"/>
+            <a:ext cx="4023360" cy="564571"/>
           </a:xfrm>
           <a:prstGeom prst="roundRect">
             <a:avLst>
@@ -4265,20 +4638,20 @@
       </p:sp>
       <p:sp>
         <p:nvSpPr>
-          <p:cNvPr id="6" name="Icône point 1 cercle"/>
+          <p:cNvPr id="10" name="Icône point 2 cercle"/>
           <p:cNvSpPr/>
           <p:nvPr/>
         </p:nvSpPr>
         <p:spPr>
           <a:xfrm>
-            <a:off x="548640" y="4505072"/>
+            <a:off x="4663440" y="4542776"/>
             <a:ext cx="402336" cy="402336"/>
           </a:xfrm>
           <a:prstGeom prst="ellipse">
             <a:avLst/>
           </a:prstGeom>
           <a:solidFill>
-            <a:schemeClr val="accent1"/>
+            <a:schemeClr val="accent3"/>
           </a:solidFill>
           <a:ln/>
         </p:spPr>
@@ -4292,7 +4665,7 @@
       </p:sp>
       <p:pic>
         <p:nvPicPr>
-          <p:cNvPr id="7" name="Icône point 1" descr="Icône point 1"/>
+          <p:cNvPr id="11" name="Icône point 2" descr="Icône point 2"/>
           <p:cNvPicPr>
             <a:picLocks noChangeAspect="1"/>
           </p:cNvPicPr>
@@ -4306,7 +4679,7 @@
         </p:blipFill>
         <p:spPr>
           <a:xfrm>
-            <a:off x="649224" y="4605656"/>
+            <a:off x="4764024" y="4643360"/>
             <a:ext cx="201168" cy="201168"/>
           </a:xfrm>
           <a:prstGeom prst="rect">
@@ -4316,14 +4689,14 @@
       </p:pic>
       <p:sp>
         <p:nvSpPr>
-          <p:cNvPr id="8" name="Text 4"/>
+          <p:cNvPr id="12" name="Text 7"/>
           <p:cNvSpPr txBox="1"/>
           <p:nvPr/>
         </p:nvSpPr>
         <p:spPr>
           <a:xfrm>
-            <a:off x="1051560" y="4431920"/>
-            <a:ext cx="3337560" cy="548640"/>
+            <a:off x="5166360" y="4483762"/>
+            <a:ext cx="3337560" cy="572869"/>
           </a:xfrm>
           <a:prstGeom prst="rect">
             <a:avLst/>
@@ -4335,30 +4708,13 @@
           <a:bodyPr wrap="square" lIns="0" tIns="0" rIns="0" bIns="0" rtlCol="0" anchor="ctr"/>
           <a:lstStyle/>
           <a:p>
-            <a:pPr marL="0" indent="0">
-              <a:buNone/>
-            </a:pPr>
-            <a:r>
-              <a:rPr lang="en-US" sz="1100" b="1" dirty="0">
-                <a:solidFill>
-                  <a:schemeClr val="tx1"/>
-                </a:solidFill>
-                <a:latin typeface="Calibri" pitchFamily="34" charset="0"/>
-                <a:ea typeface="Calibri" pitchFamily="34" charset="-122"/>
-                <a:cs typeface="Calibri" pitchFamily="34" charset="-120"/>
-              </a:rPr>
-              <a:t>Séquentiel puis parallèle : </a:t>
-            </a:r>
-            <a:r>
-              <a:rPr lang="en-US" sz="1100" dirty="0">
-                <a:solidFill>
-                  <a:schemeClr val="tx1"/>
-                </a:solidFill>
-                <a:latin typeface="Calibri" pitchFamily="34" charset="0"/>
-                <a:ea typeface="Calibri" pitchFamily="34" charset="-122"/>
-                <a:cs typeface="Calibri" pitchFamily="34" charset="-120"/>
-              </a:rPr>
-              <a:t>Préparation → Réconciliation → 2 branches simultanées (4A Finances / 4B Marketing)</a:t>
+            <a:r>
+              <a:rPr lang="fr-FR" sz="1100" b="1" dirty="0"/>
+              <a:t>Fail-Fast (Tests 1 à 5) </a:t>
+            </a:r>
+            <a:r>
+              <a:rPr lang="fr-FR" sz="1100" dirty="0"/>
+              <a:t>: arrêt immédiat au premier défaut et ligne d'alerte dans les logs Kestra</a:t>
             </a:r>
             <a:endParaRPr lang="en-US" sz="1100" dirty="0"/>
           </a:p>
@@ -4366,70 +4722,61 @@
       </p:sp>
       <p:sp>
         <p:nvSpPr>
-          <p:cNvPr id="9" name="Point clé 2"/>
-          <p:cNvSpPr/>
-          <p:nvPr/>
-        </p:nvSpPr>
-        <p:spPr>
-          <a:xfrm>
-            <a:off x="4572000" y="4395344"/>
-            <a:ext cx="4023360" cy="621792"/>
-          </a:xfrm>
-          <a:prstGeom prst="roundRect">
-            <a:avLst>
-              <a:gd name="adj" fmla="val 11765"/>
-            </a:avLst>
-          </a:prstGeom>
-          <a:solidFill>
-            <a:schemeClr val="bg1"/>
-          </a:solidFill>
-          <a:ln/>
-          <a:effectLst>
-            <a:outerShdw blurRad="76200" dist="25400" dir="5400000" algn="bl" rotWithShape="0">
-              <a:srgbClr val="000000">
-                <a:alpha val="12000"/>
-              </a:srgbClr>
-            </a:outerShdw>
-          </a:effectLst>
+          <p:cNvPr id="25" name="Slide Number Placeholder 0"/>
+          <p:cNvSpPr>
+            <a:spLocks noGrp="1"/>
+          </p:cNvSpPr>
+          <p:nvPr>
+            <p:ph type="sldNum" sz="quarter" idx="4294967295"/>
+          </p:nvPr>
+        </p:nvSpPr>
+        <p:spPr>
+          <a:xfrm>
+            <a:off x="8412480" y="4828032"/>
+            <a:ext cx="457200" cy="228600"/>
+          </a:xfrm>
+          <a:prstGeom prst="rect">
+            <a:avLst/>
+          </a:prstGeom>
+          <a:extLst>
+            <a:ext uri="{C572A759-6A51-4108-AA02-DFA0A04FC94B}">
+              <ma14:wrappingTextBoxFlag xmlns="" xmlns:ma14="http://schemas.microsoft.com/office/mac/drawingml/2011/main" val="0"/>
+            </a:ext>
+          </a:extLst>
         </p:spPr>
         <p:txBody>
           <a:bodyPr/>
-          <a:lstStyle/>
-          <a:p>
-            <a:endParaRPr lang="fr-FR"/>
-          </a:p>
-        </p:txBody>
-      </p:sp>
-      <p:sp>
-        <p:nvSpPr>
-          <p:cNvPr id="10" name="Icône point 2 cercle"/>
-          <p:cNvSpPr/>
-          <p:nvPr/>
-        </p:nvSpPr>
-        <p:spPr>
-          <a:xfrm>
-            <a:off x="4663440" y="4505072"/>
-            <a:ext cx="402336" cy="402336"/>
-          </a:xfrm>
-          <a:prstGeom prst="ellipse">
-            <a:avLst/>
-          </a:prstGeom>
-          <a:solidFill>
-            <a:schemeClr val="accent3"/>
-          </a:solidFill>
-          <a:ln/>
-        </p:spPr>
-        <p:txBody>
-          <a:bodyPr/>
-          <a:lstStyle/>
-          <a:p>
-            <a:endParaRPr lang="fr-FR"/>
+          <a:lstStyle>
+            <a:lvl1pPr>
+              <a:defRPr sz="1000">
+                <a:solidFill>
+                  <a:srgbClr val="5A6B82"/>
+                </a:solidFill>
+                <a:latin typeface="Calibri"/>
+                <a:ea typeface="Calibri"/>
+                <a:cs typeface="Calibri"/>
+              </a:defRPr>
+            </a:lvl1pPr>
+          </a:lstStyle>
+          <a:p>
+            <a:pPr algn="l"/>
+            <a:fld id="{F7021451-1387-4CA6-816F-3879F97B5CBC}" type="slidenum">
+              <a:rPr lang="en-US" b="0"/>
+              <a:t>4</a:t>
+            </a:fld>
+            <a:endParaRPr lang="en-US"/>
           </a:p>
         </p:txBody>
       </p:sp>
       <p:pic>
         <p:nvPicPr>
-          <p:cNvPr id="11" name="Icône point 2" descr="Icône point 2"/>
+          <p:cNvPr id="16" name="Image 15" descr="The image depicts a detailed flowchart for an automated monthly bottleneck process (Automatisation Mensuelle Bottleneck) within a quality control and process function (COPIL) system, involving steps such as data preparation, error checking, data reconciliation, quality checks, and generation of financial reports.&#10;&#10;Le contenu généré par l’IA peut être incorrect.">
+            <a:extLst>
+              <a:ext uri="{FF2B5EF4-FFF2-40B4-BE49-F238E27FC236}">
+                <a16:creationId xmlns:a16="http://schemas.microsoft.com/office/drawing/2014/main" id="{DAFA5111-96E5-A75E-BBB1-4FF786CA5AE2}"/>
+              </a:ext>
+            </a:extLst>
+          </p:cNvPr>
           <p:cNvPicPr>
             <a:picLocks noChangeAspect="1"/>
           </p:cNvPicPr>
@@ -4443,112 +4790,14 @@
         </p:blipFill>
         <p:spPr>
           <a:xfrm>
-            <a:off x="4764024" y="4605656"/>
-            <a:ext cx="201168" cy="201168"/>
+            <a:off x="462385" y="719174"/>
+            <a:ext cx="8041535" cy="3612162"/>
           </a:xfrm>
           <a:prstGeom prst="rect">
             <a:avLst/>
           </a:prstGeom>
         </p:spPr>
       </p:pic>
-      <p:sp>
-        <p:nvSpPr>
-          <p:cNvPr id="12" name="Text 7"/>
-          <p:cNvSpPr txBox="1"/>
-          <p:nvPr/>
-        </p:nvSpPr>
-        <p:spPr>
-          <a:xfrm>
-            <a:off x="5166360" y="4431920"/>
-            <a:ext cx="3337560" cy="548640"/>
-          </a:xfrm>
-          <a:prstGeom prst="rect">
-            <a:avLst/>
-          </a:prstGeom>
-          <a:noFill/>
-          <a:ln/>
-        </p:spPr>
-        <p:txBody>
-          <a:bodyPr wrap="square" lIns="0" tIns="0" rIns="0" bIns="0" rtlCol="0" anchor="ctr"/>
-          <a:lstStyle/>
-          <a:p>
-            <a:pPr marL="0" indent="0">
-              <a:buNone/>
-            </a:pPr>
-            <a:r>
-              <a:rPr lang="en-US" sz="1100" b="1" dirty="0">
-                <a:solidFill>
-                  <a:schemeClr val="tx1"/>
-                </a:solidFill>
-                <a:latin typeface="Calibri" pitchFamily="34" charset="0"/>
-                <a:ea typeface="Calibri" pitchFamily="34" charset="-122"/>
-                <a:cs typeface="Calibri" pitchFamily="34" charset="-120"/>
-              </a:rPr>
-              <a:t>Fail-Fast : </a:t>
-            </a:r>
-            <a:r>
-              <a:rPr lang="en-US" sz="1100" dirty="0">
-                <a:solidFill>
-                  <a:schemeClr val="tx1"/>
-                </a:solidFill>
-                <a:latin typeface="Calibri" pitchFamily="34" charset="0"/>
-                <a:ea typeface="Calibri" pitchFamily="34" charset="-122"/>
-                <a:cs typeface="Calibri" pitchFamily="34" charset="-120"/>
-              </a:rPr>
-              <a:t>chaque étape est verrouillée par un contrôle qualité avant la suivante</a:t>
-            </a:r>
-            <a:endParaRPr lang="en-US" sz="1100" dirty="0"/>
-          </a:p>
-        </p:txBody>
-      </p:sp>
-      <p:sp>
-        <p:nvSpPr>
-          <p:cNvPr id="25" name="Slide Number Placeholder 0"/>
-          <p:cNvSpPr>
-            <a:spLocks noGrp="1"/>
-          </p:cNvSpPr>
-          <p:nvPr>
-            <p:ph type="sldNum" sz="quarter" idx="4294967295"/>
-          </p:nvPr>
-        </p:nvSpPr>
-        <p:spPr>
-          <a:xfrm>
-            <a:off x="8412480" y="4828032"/>
-            <a:ext cx="457200" cy="228600"/>
-          </a:xfrm>
-          <a:prstGeom prst="rect">
-            <a:avLst/>
-          </a:prstGeom>
-          <a:extLst>
-            <a:ext uri="{C572A759-6A51-4108-AA02-DFA0A04FC94B}">
-              <ma14:wrappingTextBoxFlag xmlns="" xmlns:ma14="http://schemas.microsoft.com/office/mac/drawingml/2011/main" val="0"/>
-            </a:ext>
-          </a:extLst>
-        </p:spPr>
-        <p:txBody>
-          <a:bodyPr/>
-          <a:lstStyle>
-            <a:lvl1pPr>
-              <a:defRPr sz="1000">
-                <a:solidFill>
-                  <a:srgbClr val="5A6B82"/>
-                </a:solidFill>
-                <a:latin typeface="Calibri"/>
-                <a:ea typeface="Calibri"/>
-                <a:cs typeface="Calibri"/>
-              </a:defRPr>
-            </a:lvl1pPr>
-          </a:lstStyle>
-          <a:p>
-            <a:pPr algn="l"/>
-            <a:fld id="{F7021451-1387-4CA6-816F-3879F97B5CBC}" type="slidenum">
-              <a:rPr lang="en-US" b="0"/>
-              <a:t>4</a:t>
-            </a:fld>
-            <a:endParaRPr lang="en-US"/>
-          </a:p>
-        </p:txBody>
-      </p:sp>
     </p:spTree>
   </p:cSld>
   <p:clrMapOvr>
@@ -6512,8 +6761,8 @@
         </p:nvSpPr>
         <p:spPr>
           <a:xfrm>
-            <a:off x="411480" y="960120"/>
-            <a:ext cx="8321040" cy="1242508"/>
+            <a:off x="235670" y="960120"/>
+            <a:ext cx="8686800" cy="1242508"/>
           </a:xfrm>
           <a:prstGeom prst="rect">
             <a:avLst/>
@@ -6538,9 +6787,111 @@
           </a:p>
         </p:txBody>
       </p:sp>
+      <p:sp>
+        <p:nvSpPr>
+          <p:cNvPr id="5" name="Text 2"/>
+          <p:cNvSpPr txBox="1"/>
+          <p:nvPr/>
+        </p:nvSpPr>
+        <p:spPr>
+          <a:xfrm>
+            <a:off x="457200" y="2248348"/>
+            <a:ext cx="8229600" cy="228600"/>
+          </a:xfrm>
+          <a:prstGeom prst="rect">
+            <a:avLst/>
+          </a:prstGeom>
+          <a:noFill/>
+          <a:ln/>
+        </p:spPr>
+        <p:txBody>
+          <a:bodyPr wrap="square" lIns="0" tIns="0" rIns="0" bIns="0" rtlCol="0" anchor="t"/>
+          <a:lstStyle/>
+          <a:p>
+            <a:pPr marL="0" indent="0" algn="ctr">
+              <a:buNone/>
+            </a:pPr>
+            <a:r>
+              <a:rPr lang="en-US" sz="1000" i="1" dirty="0">
+                <a:solidFill>
+                  <a:srgbClr val="5A6B82"/>
+                </a:solidFill>
+                <a:latin typeface="Calibri" pitchFamily="34" charset="0"/>
+                <a:ea typeface="Calibri" pitchFamily="34" charset="-122"/>
+                <a:cs typeface="Calibri" pitchFamily="34" charset="-120"/>
+              </a:rPr>
+              <a:t>Vue Topologie générée automatiquement à partir du code YAML</a:t>
+            </a:r>
+            <a:endParaRPr lang="en-US" sz="1000" dirty="0"/>
+          </a:p>
+        </p:txBody>
+      </p:sp>
+      <p:sp>
+        <p:nvSpPr>
+          <p:cNvPr id="6" name="Concept Flow"/>
+          <p:cNvSpPr/>
+          <p:nvPr/>
+        </p:nvSpPr>
+        <p:spPr>
+          <a:xfrm>
+            <a:off x="457200" y="2697480"/>
+            <a:ext cx="1920240" cy="2011680"/>
+          </a:xfrm>
+          <a:prstGeom prst="roundRect">
+            <a:avLst>
+              <a:gd name="adj" fmla="val 3810"/>
+            </a:avLst>
+          </a:prstGeom>
+          <a:solidFill>
+            <a:schemeClr val="bg1"/>
+          </a:solidFill>
+          <a:ln/>
+          <a:effectLst>
+            <a:outerShdw blurRad="76200" dist="25400" dir="5400000" algn="bl" rotWithShape="0">
+              <a:srgbClr val="000000">
+                <a:alpha val="12000"/>
+              </a:srgbClr>
+            </a:outerShdw>
+          </a:effectLst>
+        </p:spPr>
+        <p:txBody>
+          <a:bodyPr/>
+          <a:lstStyle/>
+          <a:p>
+            <a:endParaRPr lang="fr-FR"/>
+          </a:p>
+        </p:txBody>
+      </p:sp>
+      <p:sp>
+        <p:nvSpPr>
+          <p:cNvPr id="7" name="Flow cercle"/>
+          <p:cNvSpPr/>
+          <p:nvPr/>
+        </p:nvSpPr>
+        <p:spPr>
+          <a:xfrm>
+            <a:off x="640080" y="2880360"/>
+            <a:ext cx="502920" cy="502920"/>
+          </a:xfrm>
+          <a:prstGeom prst="ellipse">
+            <a:avLst/>
+          </a:prstGeom>
+          <a:solidFill>
+            <a:schemeClr val="accent1"/>
+          </a:solidFill>
+          <a:ln/>
+        </p:spPr>
+        <p:txBody>
+          <a:bodyPr/>
+          <a:lstStyle/>
+          <a:p>
+            <a:endParaRPr lang="fr-FR"/>
+          </a:p>
+        </p:txBody>
+      </p:sp>
       <p:pic>
         <p:nvPicPr>
-          <p:cNvPr id="4" name="Capture topologie" descr="Vue Topologie Kestra du flow bottleneck_pipeline"/>
+          <p:cNvPr id="8" name="Flow" descr="Flow"/>
           <p:cNvPicPr>
             <a:picLocks noChangeAspect="1"/>
           </p:cNvPicPr>
@@ -6554,8 +6905,8 @@
         </p:blipFill>
         <p:spPr>
           <a:xfrm>
-            <a:off x="457200" y="1097280"/>
-            <a:ext cx="8229600" cy="968188"/>
+            <a:off x="765810" y="3006090"/>
+            <a:ext cx="251460" cy="251460"/>
           </a:xfrm>
           <a:prstGeom prst="rect">
             <a:avLst/>
@@ -6564,14 +6915,14 @@
       </p:pic>
       <p:sp>
         <p:nvSpPr>
-          <p:cNvPr id="5" name="Text 2"/>
+          <p:cNvPr id="9" name="Text 5"/>
           <p:cNvSpPr txBox="1"/>
           <p:nvPr/>
         </p:nvSpPr>
         <p:spPr>
           <a:xfrm>
-            <a:off x="457200" y="2248348"/>
-            <a:ext cx="8229600" cy="228600"/>
+            <a:off x="640080" y="3502152"/>
+            <a:ext cx="1554480" cy="274320"/>
           </a:xfrm>
           <a:prstGeom prst="rect">
             <a:avLst/>
@@ -6583,33 +6934,72 @@
           <a:bodyPr wrap="square" lIns="0" tIns="0" rIns="0" bIns="0" rtlCol="0" anchor="t"/>
           <a:lstStyle/>
           <a:p>
-            <a:pPr marL="0" indent="0" algn="ctr">
+            <a:pPr marL="0" indent="0">
               <a:buNone/>
             </a:pPr>
             <a:r>
-              <a:rPr lang="en-US" sz="1000" i="1" dirty="0">
-                <a:solidFill>
-                  <a:srgbClr val="5A6B82"/>
+              <a:rPr lang="en-US" sz="1500" b="1" dirty="0">
+                <a:solidFill>
+                  <a:schemeClr val="accent1"/>
+                </a:solidFill>
+                <a:latin typeface="Cambria" pitchFamily="34" charset="0"/>
+                <a:ea typeface="Cambria" pitchFamily="34" charset="-122"/>
+                <a:cs typeface="Cambria" pitchFamily="34" charset="-120"/>
+              </a:rPr>
+              <a:t>1. Flow</a:t>
+            </a:r>
+            <a:endParaRPr lang="en-US" sz="1500" dirty="0"/>
+          </a:p>
+        </p:txBody>
+      </p:sp>
+      <p:sp>
+        <p:nvSpPr>
+          <p:cNvPr id="10" name="Text 6"/>
+          <p:cNvSpPr txBox="1"/>
+          <p:nvPr/>
+        </p:nvSpPr>
+        <p:spPr>
+          <a:xfrm>
+            <a:off x="640080" y="3813048"/>
+            <a:ext cx="1554480" cy="822960"/>
+          </a:xfrm>
+          <a:prstGeom prst="rect">
+            <a:avLst/>
+          </a:prstGeom>
+          <a:noFill/>
+          <a:ln/>
+        </p:spPr>
+        <p:txBody>
+          <a:bodyPr wrap="square" lIns="0" tIns="0" rIns="0" bIns="0" rtlCol="0" anchor="t"/>
+          <a:lstStyle/>
+          <a:p>
+            <a:pPr marL="0" indent="0">
+              <a:buNone/>
+            </a:pPr>
+            <a:r>
+              <a:rPr lang="en-US" sz="1200" dirty="0">
+                <a:solidFill>
+                  <a:schemeClr val="tx1"/>
                 </a:solidFill>
                 <a:latin typeface="Calibri" pitchFamily="34" charset="0"/>
                 <a:ea typeface="Calibri" pitchFamily="34" charset="-122"/>
                 <a:cs typeface="Calibri" pitchFamily="34" charset="-120"/>
               </a:rPr>
-              <a:t>Vue Topologie générée automatiquement à partir du code YAML</a:t>
-            </a:r>
-            <a:endParaRPr lang="en-US" sz="1000" dirty="0"/>
-          </a:p>
-        </p:txBody>
-      </p:sp>
-      <p:sp>
-        <p:nvSpPr>
-          <p:cNvPr id="6" name="Concept Flow"/>
+              <a:t>bottleneck_pipeline : le plan de marche global, dans un fichier YAML unique et lisible.</a:t>
+            </a:r>
+            <a:endParaRPr lang="en-US" sz="1200" dirty="0"/>
+          </a:p>
+        </p:txBody>
+      </p:sp>
+      <p:sp>
+        <p:nvSpPr>
+          <p:cNvPr id="11" name="Concept Tasks"/>
           <p:cNvSpPr/>
           <p:nvPr/>
         </p:nvSpPr>
         <p:spPr>
           <a:xfrm>
-            <a:off x="457200" y="2697480"/>
+            <a:off x="2560320" y="2697480"/>
             <a:ext cx="1920240" cy="2011680"/>
           </a:xfrm>
           <a:prstGeom prst="roundRect">
@@ -6639,20 +7029,20 @@
       </p:sp>
       <p:sp>
         <p:nvSpPr>
-          <p:cNvPr id="7" name="Flow cercle"/>
+          <p:cNvPr id="12" name="Tasks cercle"/>
           <p:cNvSpPr/>
           <p:nvPr/>
         </p:nvSpPr>
         <p:spPr>
           <a:xfrm>
-            <a:off x="640080" y="2880360"/>
+            <a:off x="2743200" y="2880360"/>
             <a:ext cx="502920" cy="502920"/>
           </a:xfrm>
           <a:prstGeom prst="ellipse">
             <a:avLst/>
           </a:prstGeom>
           <a:solidFill>
-            <a:schemeClr val="accent1"/>
+            <a:schemeClr val="accent2"/>
           </a:solidFill>
           <a:ln/>
         </p:spPr>
@@ -6666,7 +7056,7 @@
       </p:sp>
       <p:pic>
         <p:nvPicPr>
-          <p:cNvPr id="8" name="Flow" descr="Flow"/>
+          <p:cNvPr id="13" name="Tasks" descr="Tasks"/>
           <p:cNvPicPr>
             <a:picLocks noChangeAspect="1"/>
           </p:cNvPicPr>
@@ -6680,7 +7070,7 @@
         </p:blipFill>
         <p:spPr>
           <a:xfrm>
-            <a:off x="765810" y="3006090"/>
+            <a:off x="2868930" y="3006090"/>
             <a:ext cx="251460" cy="251460"/>
           </a:xfrm>
           <a:prstGeom prst="rect">
@@ -6690,13 +7080,13 @@
       </p:pic>
       <p:sp>
         <p:nvSpPr>
-          <p:cNvPr id="9" name="Text 5"/>
+          <p:cNvPr id="14" name="Text 9"/>
           <p:cNvSpPr txBox="1"/>
           <p:nvPr/>
         </p:nvSpPr>
         <p:spPr>
           <a:xfrm>
-            <a:off x="640080" y="3502152"/>
+            <a:off x="2743200" y="3502152"/>
             <a:ext cx="1554480" cy="274320"/>
           </a:xfrm>
           <a:prstGeom prst="rect">
@@ -6715,13 +7105,13 @@
             <a:r>
               <a:rPr lang="en-US" sz="1500" b="1" dirty="0">
                 <a:solidFill>
-                  <a:schemeClr val="accent1"/>
+                  <a:schemeClr val="accent2"/>
                 </a:solidFill>
                 <a:latin typeface="Cambria" pitchFamily="34" charset="0"/>
                 <a:ea typeface="Cambria" pitchFamily="34" charset="-122"/>
                 <a:cs typeface="Cambria" pitchFamily="34" charset="-120"/>
               </a:rPr>
-              <a:t>1. Flow</a:t>
+              <a:t>2. Tasks</a:t>
             </a:r>
             <a:endParaRPr lang="en-US" sz="1500" dirty="0"/>
           </a:p>
@@ -6729,13 +7119,13 @@
       </p:sp>
       <p:sp>
         <p:nvSpPr>
-          <p:cNvPr id="10" name="Text 6"/>
+          <p:cNvPr id="15" name="Text 10"/>
           <p:cNvSpPr txBox="1"/>
           <p:nvPr/>
         </p:nvSpPr>
         <p:spPr>
           <a:xfrm>
-            <a:off x="640080" y="3813048"/>
+            <a:off x="2743200" y="3813048"/>
             <a:ext cx="1554480" cy="822960"/>
           </a:xfrm>
           <a:prstGeom prst="rect">
@@ -6760,7 +7150,7 @@
                 <a:ea typeface="Calibri" pitchFamily="34" charset="-122"/>
                 <a:cs typeface="Calibri" pitchFamily="34" charset="-120"/>
               </a:rPr>
-              <a:t>bottleneck_pipeline : le plan de marche global, dans un fichier YAML unique et lisible.</a:t>
+              <a:t>Les briques unitaires : une transformation de données ou un test de contrôle.</a:t>
             </a:r>
             <a:endParaRPr lang="en-US" sz="1200" dirty="0"/>
           </a:p>
@@ -6768,13 +7158,13 @@
       </p:sp>
       <p:sp>
         <p:nvSpPr>
-          <p:cNvPr id="11" name="Concept Tasks"/>
+          <p:cNvPr id="16" name="Concept Parallel"/>
           <p:cNvSpPr/>
           <p:nvPr/>
         </p:nvSpPr>
         <p:spPr>
           <a:xfrm>
-            <a:off x="2560320" y="2697480"/>
+            <a:off x="4663440" y="2697480"/>
             <a:ext cx="1920240" cy="2011680"/>
           </a:xfrm>
           <a:prstGeom prst="roundRect">
@@ -6804,20 +7194,20 @@
       </p:sp>
       <p:sp>
         <p:nvSpPr>
-          <p:cNvPr id="12" name="Tasks cercle"/>
+          <p:cNvPr id="17" name="Parallel cercle"/>
           <p:cNvSpPr/>
           <p:nvPr/>
         </p:nvSpPr>
         <p:spPr>
           <a:xfrm>
-            <a:off x="2743200" y="2880360"/>
+            <a:off x="4846320" y="2880360"/>
             <a:ext cx="502920" cy="502920"/>
           </a:xfrm>
           <a:prstGeom prst="ellipse">
             <a:avLst/>
           </a:prstGeom>
           <a:solidFill>
-            <a:schemeClr val="accent2"/>
+            <a:schemeClr val="accent3"/>
           </a:solidFill>
           <a:ln/>
         </p:spPr>
@@ -6831,7 +7221,7 @@
       </p:sp>
       <p:pic>
         <p:nvPicPr>
-          <p:cNvPr id="13" name="Tasks" descr="Tasks"/>
+          <p:cNvPr id="18" name="Parallel" descr="Parallel"/>
           <p:cNvPicPr>
             <a:picLocks noChangeAspect="1"/>
           </p:cNvPicPr>
@@ -6845,7 +7235,7 @@
         </p:blipFill>
         <p:spPr>
           <a:xfrm>
-            <a:off x="2868930" y="3006090"/>
+            <a:off x="4972050" y="3006090"/>
             <a:ext cx="251460" cy="251460"/>
           </a:xfrm>
           <a:prstGeom prst="rect">
@@ -6855,13 +7245,13 @@
       </p:pic>
       <p:sp>
         <p:nvSpPr>
-          <p:cNvPr id="14" name="Text 9"/>
+          <p:cNvPr id="19" name="Text 13"/>
           <p:cNvSpPr txBox="1"/>
           <p:nvPr/>
         </p:nvSpPr>
         <p:spPr>
           <a:xfrm>
-            <a:off x="2743200" y="3502152"/>
+            <a:off x="4846320" y="3502152"/>
             <a:ext cx="1554480" cy="274320"/>
           </a:xfrm>
           <a:prstGeom prst="rect">
@@ -6880,13 +7270,13 @@
             <a:r>
               <a:rPr lang="en-US" sz="1500" b="1" dirty="0">
                 <a:solidFill>
-                  <a:schemeClr val="accent2"/>
+                  <a:schemeClr val="accent3"/>
                 </a:solidFill>
                 <a:latin typeface="Cambria" pitchFamily="34" charset="0"/>
                 <a:ea typeface="Cambria" pitchFamily="34" charset="-122"/>
                 <a:cs typeface="Cambria" pitchFamily="34" charset="-120"/>
               </a:rPr>
-              <a:t>2. Tasks</a:t>
+              <a:t>3. Parallel</a:t>
             </a:r>
             <a:endParaRPr lang="en-US" sz="1500" dirty="0"/>
           </a:p>
@@ -6894,13 +7284,13 @@
       </p:sp>
       <p:sp>
         <p:nvSpPr>
-          <p:cNvPr id="15" name="Text 10"/>
+          <p:cNvPr id="20" name="Text 14"/>
           <p:cNvSpPr txBox="1"/>
           <p:nvPr/>
         </p:nvSpPr>
         <p:spPr>
           <a:xfrm>
-            <a:off x="2743200" y="3813048"/>
+            <a:off x="4846320" y="3813048"/>
             <a:ext cx="1554480" cy="822960"/>
           </a:xfrm>
           <a:prstGeom prst="rect">
@@ -6913,19 +7303,9 @@
           <a:bodyPr wrap="square" lIns="0" tIns="0" rIns="0" bIns="0" rtlCol="0" anchor="t"/>
           <a:lstStyle/>
           <a:p>
-            <a:pPr marL="0" indent="0">
-              <a:buNone/>
-            </a:pPr>
-            <a:r>
-              <a:rPr lang="en-US" sz="1200" dirty="0">
-                <a:solidFill>
-                  <a:schemeClr val="tx1"/>
-                </a:solidFill>
-                <a:latin typeface="Calibri" pitchFamily="34" charset="0"/>
-                <a:ea typeface="Calibri" pitchFamily="34" charset="-122"/>
-                <a:cs typeface="Calibri" pitchFamily="34" charset="-120"/>
-              </a:rPr>
-              <a:t>Les briques unitaires : une transformation de données ou un test de contrôle.</a:t>
+            <a:r>
+              <a:rPr lang="fr-FR" sz="1200" dirty="0"/>
+              <a:t>Calculs séquencés ; seuls les exports finaux (Excel et CSV) sont exécutés en parallèle.</a:t>
             </a:r>
             <a:endParaRPr lang="en-US" sz="1200" dirty="0"/>
           </a:p>
@@ -6933,13 +7313,13 @@
       </p:sp>
       <p:sp>
         <p:nvSpPr>
-          <p:cNvPr id="16" name="Concept Parallel"/>
+          <p:cNvPr id="21" name="Concept Trigger"/>
           <p:cNvSpPr/>
           <p:nvPr/>
         </p:nvSpPr>
         <p:spPr>
           <a:xfrm>
-            <a:off x="4663440" y="2697480"/>
+            <a:off x="6766560" y="2697480"/>
             <a:ext cx="1920240" cy="2011680"/>
           </a:xfrm>
           <a:prstGeom prst="roundRect">
@@ -6969,20 +7349,20 @@
       </p:sp>
       <p:sp>
         <p:nvSpPr>
-          <p:cNvPr id="17" name="Parallel cercle"/>
+          <p:cNvPr id="22" name="Trigger cercle"/>
           <p:cNvSpPr/>
           <p:nvPr/>
         </p:nvSpPr>
         <p:spPr>
           <a:xfrm>
-            <a:off x="4846320" y="2880360"/>
+            <a:off x="6949440" y="2880360"/>
             <a:ext cx="502920" cy="502920"/>
           </a:xfrm>
           <a:prstGeom prst="ellipse">
             <a:avLst/>
           </a:prstGeom>
           <a:solidFill>
-            <a:schemeClr val="accent3"/>
+            <a:schemeClr val="accent4"/>
           </a:solidFill>
           <a:ln/>
         </p:spPr>
@@ -6996,7 +7376,7 @@
       </p:sp>
       <p:pic>
         <p:nvPicPr>
-          <p:cNvPr id="18" name="Parallel" descr="Parallel"/>
+          <p:cNvPr id="23" name="Trigger" descr="Trigger"/>
           <p:cNvPicPr>
             <a:picLocks noChangeAspect="1"/>
           </p:cNvPicPr>
@@ -7010,171 +7390,6 @@
         </p:blipFill>
         <p:spPr>
           <a:xfrm>
-            <a:off x="4972050" y="3006090"/>
-            <a:ext cx="251460" cy="251460"/>
-          </a:xfrm>
-          <a:prstGeom prst="rect">
-            <a:avLst/>
-          </a:prstGeom>
-        </p:spPr>
-      </p:pic>
-      <p:sp>
-        <p:nvSpPr>
-          <p:cNvPr id="19" name="Text 13"/>
-          <p:cNvSpPr txBox="1"/>
-          <p:nvPr/>
-        </p:nvSpPr>
-        <p:spPr>
-          <a:xfrm>
-            <a:off x="4846320" y="3502152"/>
-            <a:ext cx="1554480" cy="274320"/>
-          </a:xfrm>
-          <a:prstGeom prst="rect">
-            <a:avLst/>
-          </a:prstGeom>
-          <a:noFill/>
-          <a:ln/>
-        </p:spPr>
-        <p:txBody>
-          <a:bodyPr wrap="square" lIns="0" tIns="0" rIns="0" bIns="0" rtlCol="0" anchor="t"/>
-          <a:lstStyle/>
-          <a:p>
-            <a:pPr marL="0" indent="0">
-              <a:buNone/>
-            </a:pPr>
-            <a:r>
-              <a:rPr lang="en-US" sz="1500" b="1" dirty="0">
-                <a:solidFill>
-                  <a:schemeClr val="accent3"/>
-                </a:solidFill>
-                <a:latin typeface="Cambria" pitchFamily="34" charset="0"/>
-                <a:ea typeface="Cambria" pitchFamily="34" charset="-122"/>
-                <a:cs typeface="Cambria" pitchFamily="34" charset="-120"/>
-              </a:rPr>
-              <a:t>3. Parallel</a:t>
-            </a:r>
-            <a:endParaRPr lang="en-US" sz="1500" dirty="0"/>
-          </a:p>
-        </p:txBody>
-      </p:sp>
-      <p:sp>
-        <p:nvSpPr>
-          <p:cNvPr id="20" name="Text 14"/>
-          <p:cNvSpPr txBox="1"/>
-          <p:nvPr/>
-        </p:nvSpPr>
-        <p:spPr>
-          <a:xfrm>
-            <a:off x="4846320" y="3813048"/>
-            <a:ext cx="1554480" cy="822960"/>
-          </a:xfrm>
-          <a:prstGeom prst="rect">
-            <a:avLst/>
-          </a:prstGeom>
-          <a:noFill/>
-          <a:ln/>
-        </p:spPr>
-        <p:txBody>
-          <a:bodyPr wrap="square" lIns="0" tIns="0" rIns="0" bIns="0" rtlCol="0" anchor="t"/>
-          <a:lstStyle/>
-          <a:p>
-            <a:pPr marL="0" indent="0">
-              <a:buNone/>
-            </a:pPr>
-            <a:r>
-              <a:rPr lang="en-US" sz="1200" dirty="0">
-                <a:solidFill>
-                  <a:schemeClr val="tx1"/>
-                </a:solidFill>
-                <a:latin typeface="Calibri" pitchFamily="34" charset="0"/>
-                <a:ea typeface="Calibri" pitchFamily="34" charset="-122"/>
-                <a:cs typeface="Calibri" pitchFamily="34" charset="-120"/>
-              </a:rPr>
-              <a:t>Branches CA et Z-Score exécutées en même temps.</a:t>
-            </a:r>
-            <a:endParaRPr lang="en-US" sz="1200" dirty="0"/>
-          </a:p>
-        </p:txBody>
-      </p:sp>
-      <p:sp>
-        <p:nvSpPr>
-          <p:cNvPr id="21" name="Concept Trigger"/>
-          <p:cNvSpPr/>
-          <p:nvPr/>
-        </p:nvSpPr>
-        <p:spPr>
-          <a:xfrm>
-            <a:off x="6766560" y="2697480"/>
-            <a:ext cx="1920240" cy="2011680"/>
-          </a:xfrm>
-          <a:prstGeom prst="roundRect">
-            <a:avLst>
-              <a:gd name="adj" fmla="val 3810"/>
-            </a:avLst>
-          </a:prstGeom>
-          <a:solidFill>
-            <a:schemeClr val="bg1"/>
-          </a:solidFill>
-          <a:ln/>
-          <a:effectLst>
-            <a:outerShdw blurRad="76200" dist="25400" dir="5400000" algn="bl" rotWithShape="0">
-              <a:srgbClr val="000000">
-                <a:alpha val="12000"/>
-              </a:srgbClr>
-            </a:outerShdw>
-          </a:effectLst>
-        </p:spPr>
-        <p:txBody>
-          <a:bodyPr/>
-          <a:lstStyle/>
-          <a:p>
-            <a:endParaRPr lang="fr-FR"/>
-          </a:p>
-        </p:txBody>
-      </p:sp>
-      <p:sp>
-        <p:nvSpPr>
-          <p:cNvPr id="22" name="Trigger cercle"/>
-          <p:cNvSpPr/>
-          <p:nvPr/>
-        </p:nvSpPr>
-        <p:spPr>
-          <a:xfrm>
-            <a:off x="6949440" y="2880360"/>
-            <a:ext cx="502920" cy="502920"/>
-          </a:xfrm>
-          <a:prstGeom prst="ellipse">
-            <a:avLst/>
-          </a:prstGeom>
-          <a:solidFill>
-            <a:schemeClr val="accent4"/>
-          </a:solidFill>
-          <a:ln/>
-        </p:spPr>
-        <p:txBody>
-          <a:bodyPr/>
-          <a:lstStyle/>
-          <a:p>
-            <a:endParaRPr lang="fr-FR"/>
-          </a:p>
-        </p:txBody>
-      </p:sp>
-      <p:pic>
-        <p:nvPicPr>
-          <p:cNvPr id="23" name="Trigger" descr="Trigger"/>
-          <p:cNvPicPr>
-            <a:picLocks noChangeAspect="1"/>
-          </p:cNvPicPr>
-          <p:nvPr/>
-        </p:nvPicPr>
-        <p:blipFill>
-          <a:blip r:embed="rId7"/>
-          <a:stretch>
-            <a:fillRect/>
-          </a:stretch>
-        </p:blipFill>
-        <p:spPr>
-          <a:xfrm>
             <a:off x="7075170" y="3006090"/>
             <a:ext cx="251460" cy="251460"/>
           </a:xfrm>
@@ -7243,19 +7458,9 @@
           <a:bodyPr wrap="square" lIns="0" tIns="0" rIns="0" bIns="0" rtlCol="0" anchor="t"/>
           <a:lstStyle/>
           <a:p>
-            <a:pPr marL="0" indent="0">
-              <a:buNone/>
-            </a:pPr>
-            <a:r>
-              <a:rPr lang="en-US" sz="1200" dirty="0">
-                <a:solidFill>
-                  <a:schemeClr val="tx1"/>
-                </a:solidFill>
-                <a:latin typeface="Calibri" pitchFamily="34" charset="0"/>
-                <a:ea typeface="Calibri" pitchFamily="34" charset="-122"/>
-                <a:cs typeface="Calibri" pitchFamily="34" charset="-120"/>
-              </a:rPr>
-              <a:t>L'horloge interne : Cron 0 9 15 * *, le 15 de chaque mois à 09h00.</a:t>
+            <a:r>
+              <a:rPr lang="fr-FR" sz="1200" dirty="0"/>
+              <a:t>Cron 0 9 15 * * : le 15 de chaque mois à 09h00 (heure de Paris) en mode production</a:t>
             </a:r>
             <a:endParaRPr lang="en-US" sz="1200" dirty="0"/>
           </a:p>
@@ -7309,6 +7514,37 @@
           </a:p>
         </p:txBody>
       </p:sp>
+      <p:pic>
+        <p:nvPicPr>
+          <p:cNvPr id="28" name="Image 27" descr="The image shows a visual representation of a flow diagram with various code elements, process names, and file references.&#10;&#10;Le contenu généré par l’IA peut être incorrect.">
+            <a:extLst>
+              <a:ext uri="{FF2B5EF4-FFF2-40B4-BE49-F238E27FC236}">
+                <a16:creationId xmlns:a16="http://schemas.microsoft.com/office/drawing/2014/main" id="{3F9E706D-4A35-D739-3D53-4517A179C8CC}"/>
+              </a:ext>
+            </a:extLst>
+          </p:cNvPr>
+          <p:cNvPicPr>
+            <a:picLocks noChangeAspect="1"/>
+          </p:cNvPicPr>
+          <p:nvPr/>
+        </p:nvPicPr>
+        <p:blipFill>
+          <a:blip r:embed="rId7"/>
+          <a:srcRect l="5000" t="47682" r="3000" b="28144"/>
+          <a:stretch>
+            <a:fillRect/>
+          </a:stretch>
+        </p:blipFill>
+        <p:spPr>
+          <a:xfrm>
+            <a:off x="274320" y="1072226"/>
+            <a:ext cx="8595360" cy="1010120"/>
+          </a:xfrm>
+          <a:prstGeom prst="rect">
+            <a:avLst/>
+          </a:prstGeom>
+        </p:spPr>
+      </p:pic>
     </p:spTree>
   </p:cSld>
   <p:clrMapOvr>
@@ -7386,14 +7622,14 @@
           <p:nvPr>
             <p:extLst>
               <p:ext uri="{D42A27DB-BD31-4B8C-83A1-F6EECF244321}">
-                <p14:modId xmlns:p14="http://schemas.microsoft.com/office/powerpoint/2010/main" val="2160440022"/>
+                <p14:modId xmlns:p14="http://schemas.microsoft.com/office/powerpoint/2010/main" val="288352295"/>
               </p:ext>
             </p:extLst>
           </p:nvPr>
         </p:nvGraphicFramePr>
         <p:xfrm>
-          <a:off x="457200" y="914400"/>
-          <a:ext cx="8229600" cy="2103120"/>
+          <a:off x="457200" y="768283"/>
+          <a:ext cx="8229600" cy="2468880"/>
         </p:xfrm>
         <a:graphic>
           <a:graphicData uri="http://schemas.openxmlformats.org/drawingml/2006/table">
@@ -8711,6 +8947,426 @@
                   </a:ext>
                 </a:extLst>
               </a:tr>
+              <a:tr h="365760">
+                <a:tc>
+                  <a:txBody>
+                    <a:bodyPr/>
+                    <a:lstStyle/>
+                    <a:p>
+                      <a:pPr marL="0" indent="0">
+                        <a:buNone/>
+                      </a:pPr>
+                      <a:r>
+                        <a:rPr lang="en-US" sz="1100" b="1" dirty="0">
+                          <a:solidFill>
+                            <a:srgbClr val="1A365D"/>
+                          </a:solidFill>
+                          <a:latin typeface="Calibri" pitchFamily="34" charset="0"/>
+                          <a:ea typeface="Calibri" pitchFamily="34" charset="-122"/>
+                          <a:cs typeface="Calibri" pitchFamily="34" charset="-120"/>
+                        </a:rPr>
+                        <a:t>Test 5 — </a:t>
+                      </a:r>
+                      <a:r>
+                        <a:rPr lang="en-US" sz="1100" b="1" dirty="0" err="1">
+                          <a:solidFill>
+                            <a:srgbClr val="1A365D"/>
+                          </a:solidFill>
+                          <a:latin typeface="Calibri" pitchFamily="34" charset="0"/>
+                          <a:ea typeface="Calibri" pitchFamily="34" charset="-122"/>
+                          <a:cs typeface="Calibri" pitchFamily="34" charset="-120"/>
+                        </a:rPr>
+                        <a:t>Intégrité</a:t>
+                      </a:r>
+                      <a:r>
+                        <a:rPr lang="en-US" sz="1100" b="1" dirty="0">
+                          <a:solidFill>
+                            <a:srgbClr val="1A365D"/>
+                          </a:solidFill>
+                          <a:latin typeface="Calibri" pitchFamily="34" charset="0"/>
+                          <a:ea typeface="Calibri" pitchFamily="34" charset="-122"/>
+                          <a:cs typeface="Calibri" pitchFamily="34" charset="-120"/>
+                        </a:rPr>
+                        <a:t> et Publication</a:t>
+                      </a:r>
+                      <a:endParaRPr lang="en-US" sz="1100" dirty="0">
+                        <a:latin typeface="Calibri" charset="0"/>
+                        <a:ea typeface="Calibri" charset="0"/>
+                        <a:cs typeface="Calibri" charset="0"/>
+                      </a:endParaRPr>
+                    </a:p>
+                  </a:txBody>
+                  <a:tcPr marL="73152" marR="73152" marT="0" marB="0" anchor="ctr">
+                    <a:lnL w="6350" cap="flat" cmpd="sng" algn="ctr">
+                      <a:solidFill>
+                        <a:srgbClr val="D5DBE5"/>
+                      </a:solidFill>
+                      <a:prstDash val="solid"/>
+                      <a:round/>
+                      <a:headEnd type="none" w="med" len="med"/>
+                      <a:tailEnd type="none" w="med" len="med"/>
+                    </a:lnL>
+                    <a:lnR w="6350" cap="flat" cmpd="sng" algn="ctr">
+                      <a:solidFill>
+                        <a:srgbClr val="D5DBE5"/>
+                      </a:solidFill>
+                      <a:prstDash val="solid"/>
+                      <a:round/>
+                      <a:headEnd type="none" w="med" len="med"/>
+                      <a:tailEnd type="none" w="med" len="med"/>
+                    </a:lnR>
+                    <a:lnT w="6350" cap="flat" cmpd="sng" algn="ctr">
+                      <a:solidFill>
+                        <a:srgbClr val="D5DBE5"/>
+                      </a:solidFill>
+                      <a:prstDash val="solid"/>
+                      <a:round/>
+                      <a:headEnd type="none" w="med" len="med"/>
+                      <a:tailEnd type="none" w="med" len="med"/>
+                    </a:lnT>
+                    <a:lnB w="6350" cap="flat" cmpd="sng" algn="ctr">
+                      <a:solidFill>
+                        <a:srgbClr val="D5DBE5"/>
+                      </a:solidFill>
+                      <a:prstDash val="solid"/>
+                      <a:round/>
+                      <a:headEnd type="none" w="med" len="med"/>
+                      <a:tailEnd type="none" w="med" len="med"/>
+                    </a:lnB>
+                    <a:solidFill>
+                      <a:srgbClr val="FFFFFF"/>
+                    </a:solidFill>
+                  </a:tcPr>
+                </a:tc>
+                <a:tc>
+                  <a:txBody>
+                    <a:bodyPr/>
+                    <a:lstStyle/>
+                    <a:p>
+                      <a:pPr marL="0" indent="0">
+                        <a:buNone/>
+                      </a:pPr>
+                      <a:r>
+                        <a:rPr lang="en-US" sz="1100" dirty="0">
+                          <a:solidFill>
+                            <a:srgbClr val="1F2937"/>
+                          </a:solidFill>
+                          <a:latin typeface="Calibri" pitchFamily="34" charset="0"/>
+                          <a:ea typeface="Calibri" pitchFamily="34" charset="-122"/>
+                          <a:cs typeface="Calibri" pitchFamily="34" charset="-120"/>
+                        </a:rPr>
+                        <a:t>Controle </a:t>
+                      </a:r>
+                      <a:r>
+                        <a:rPr lang="en-US" sz="1100" dirty="0" err="1">
+                          <a:solidFill>
+                            <a:srgbClr val="1F2937"/>
+                          </a:solidFill>
+                          <a:latin typeface="Calibri" pitchFamily="34" charset="0"/>
+                          <a:ea typeface="Calibri" pitchFamily="34" charset="-122"/>
+                          <a:cs typeface="Calibri" pitchFamily="34" charset="-120"/>
+                        </a:rPr>
+                        <a:t>d’absence</a:t>
+                      </a:r>
+                      <a:r>
+                        <a:rPr lang="en-US" sz="1100" dirty="0">
+                          <a:solidFill>
+                            <a:srgbClr val="1F2937"/>
+                          </a:solidFill>
+                          <a:latin typeface="Calibri" pitchFamily="34" charset="0"/>
+                          <a:ea typeface="Calibri" pitchFamily="34" charset="-122"/>
+                          <a:cs typeface="Calibri" pitchFamily="34" charset="-120"/>
+                        </a:rPr>
+                        <a:t> de </a:t>
+                      </a:r>
+                      <a:r>
+                        <a:rPr lang="en-US" sz="1100" dirty="0" err="1">
+                          <a:solidFill>
+                            <a:srgbClr val="1F2937"/>
+                          </a:solidFill>
+                          <a:latin typeface="Calibri" pitchFamily="34" charset="0"/>
+                          <a:ea typeface="Calibri" pitchFamily="34" charset="-122"/>
+                          <a:cs typeface="Calibri" pitchFamily="34" charset="-120"/>
+                        </a:rPr>
+                        <a:t>valeurs</a:t>
+                      </a:r>
+                      <a:r>
+                        <a:rPr lang="en-US" sz="1100" dirty="0">
+                          <a:solidFill>
+                            <a:srgbClr val="1F2937"/>
+                          </a:solidFill>
+                          <a:latin typeface="Calibri" pitchFamily="34" charset="0"/>
+                          <a:ea typeface="Calibri" pitchFamily="34" charset="-122"/>
+                          <a:cs typeface="Calibri" pitchFamily="34" charset="-120"/>
+                        </a:rPr>
+                        <a:t> </a:t>
+                      </a:r>
+                      <a:r>
+                        <a:rPr lang="en-US" sz="1100" dirty="0" err="1">
+                          <a:solidFill>
+                            <a:srgbClr val="1F2937"/>
+                          </a:solidFill>
+                          <a:latin typeface="Calibri" pitchFamily="34" charset="0"/>
+                          <a:ea typeface="Calibri" pitchFamily="34" charset="-122"/>
+                          <a:cs typeface="Calibri" pitchFamily="34" charset="-120"/>
+                        </a:rPr>
+                        <a:t>manquantes</a:t>
+                      </a:r>
+                      <a:r>
+                        <a:rPr lang="en-US" sz="1100" dirty="0">
+                          <a:solidFill>
+                            <a:srgbClr val="1F2937"/>
+                          </a:solidFill>
+                          <a:latin typeface="Calibri" pitchFamily="34" charset="0"/>
+                          <a:ea typeface="Calibri" pitchFamily="34" charset="-122"/>
+                          <a:cs typeface="Calibri" pitchFamily="34" charset="-120"/>
+                        </a:rPr>
+                        <a:t> sur les champs </a:t>
+                      </a:r>
+                      <a:r>
+                        <a:rPr lang="en-US" sz="1100" dirty="0" err="1">
+                          <a:solidFill>
+                            <a:srgbClr val="1F2937"/>
+                          </a:solidFill>
+                          <a:latin typeface="Calibri" pitchFamily="34" charset="0"/>
+                          <a:ea typeface="Calibri" pitchFamily="34" charset="-122"/>
+                          <a:cs typeface="Calibri" pitchFamily="34" charset="-120"/>
+                        </a:rPr>
+                        <a:t>obligatoire</a:t>
+                      </a:r>
+                      <a:r>
+                        <a:rPr lang="en-US" sz="1100" dirty="0">
+                          <a:solidFill>
+                            <a:srgbClr val="1F2937"/>
+                          </a:solidFill>
+                          <a:latin typeface="Calibri" pitchFamily="34" charset="0"/>
+                          <a:ea typeface="Calibri" pitchFamily="34" charset="-122"/>
+                          <a:cs typeface="Calibri" pitchFamily="34" charset="-120"/>
+                        </a:rPr>
+                        <a:t> des </a:t>
+                      </a:r>
+                      <a:r>
+                        <a:rPr lang="en-US" sz="1100" dirty="0" err="1">
+                          <a:solidFill>
+                            <a:srgbClr val="1F2937"/>
+                          </a:solidFill>
+                          <a:latin typeface="Calibri" pitchFamily="34" charset="0"/>
+                          <a:ea typeface="Calibri" pitchFamily="34" charset="-122"/>
+                          <a:cs typeface="Calibri" pitchFamily="34" charset="-120"/>
+                        </a:rPr>
+                        <a:t>livrables</a:t>
+                      </a:r>
+                      <a:r>
+                        <a:rPr lang="en-US" sz="1100" dirty="0">
+                          <a:solidFill>
+                            <a:srgbClr val="1F2937"/>
+                          </a:solidFill>
+                          <a:latin typeface="Calibri" pitchFamily="34" charset="0"/>
+                          <a:ea typeface="Calibri" pitchFamily="34" charset="-122"/>
+                          <a:cs typeface="Calibri" pitchFamily="34" charset="-120"/>
+                        </a:rPr>
+                        <a:t> et validation du staging</a:t>
+                      </a:r>
+                      <a:endParaRPr lang="en-US" sz="1100" dirty="0">
+                        <a:latin typeface="Calibri" charset="0"/>
+                        <a:ea typeface="Calibri" charset="0"/>
+                        <a:cs typeface="Calibri" charset="0"/>
+                      </a:endParaRPr>
+                    </a:p>
+                  </a:txBody>
+                  <a:tcPr marL="73152" marR="73152" marT="0" marB="0" anchor="ctr">
+                    <a:lnL w="6350" cap="flat" cmpd="sng" algn="ctr">
+                      <a:solidFill>
+                        <a:srgbClr val="D5DBE5"/>
+                      </a:solidFill>
+                      <a:prstDash val="solid"/>
+                      <a:round/>
+                      <a:headEnd type="none" w="med" len="med"/>
+                      <a:tailEnd type="none" w="med" len="med"/>
+                    </a:lnL>
+                    <a:lnR w="6350" cap="flat" cmpd="sng" algn="ctr">
+                      <a:solidFill>
+                        <a:srgbClr val="D5DBE5"/>
+                      </a:solidFill>
+                      <a:prstDash val="solid"/>
+                      <a:round/>
+                      <a:headEnd type="none" w="med" len="med"/>
+                      <a:tailEnd type="none" w="med" len="med"/>
+                    </a:lnR>
+                    <a:lnT w="6350" cap="flat" cmpd="sng" algn="ctr">
+                      <a:solidFill>
+                        <a:srgbClr val="D5DBE5"/>
+                      </a:solidFill>
+                      <a:prstDash val="solid"/>
+                      <a:round/>
+                      <a:headEnd type="none" w="med" len="med"/>
+                      <a:tailEnd type="none" w="med" len="med"/>
+                    </a:lnT>
+                    <a:lnB w="6350" cap="flat" cmpd="sng" algn="ctr">
+                      <a:solidFill>
+                        <a:srgbClr val="D5DBE5"/>
+                      </a:solidFill>
+                      <a:prstDash val="solid"/>
+                      <a:round/>
+                      <a:headEnd type="none" w="med" len="med"/>
+                      <a:tailEnd type="none" w="med" len="med"/>
+                    </a:lnB>
+                    <a:solidFill>
+                      <a:srgbClr val="FFFFFF"/>
+                    </a:solidFill>
+                  </a:tcPr>
+                </a:tc>
+                <a:tc>
+                  <a:txBody>
+                    <a:bodyPr/>
+                    <a:lstStyle/>
+                    <a:p>
+                      <a:pPr marL="0" indent="0">
+                        <a:buNone/>
+                      </a:pPr>
+                      <a:r>
+                        <a:rPr lang="en-US" sz="1100" b="1" dirty="0" err="1">
+                          <a:solidFill>
+                            <a:srgbClr val="22543D"/>
+                          </a:solidFill>
+                          <a:latin typeface="Calibri" pitchFamily="34" charset="0"/>
+                          <a:ea typeface="Calibri" pitchFamily="34" charset="-122"/>
+                          <a:cs typeface="Calibri" pitchFamily="34" charset="-120"/>
+                        </a:rPr>
+                        <a:t>Fichiers</a:t>
+                      </a:r>
+                      <a:r>
+                        <a:rPr lang="en-US" sz="1100" b="1" dirty="0">
+                          <a:solidFill>
+                            <a:srgbClr val="22543D"/>
+                          </a:solidFill>
+                          <a:latin typeface="Calibri" pitchFamily="34" charset="0"/>
+                          <a:ea typeface="Calibri" pitchFamily="34" charset="-122"/>
+                          <a:cs typeface="Calibri" pitchFamily="34" charset="-120"/>
+                        </a:rPr>
+                        <a:t> </a:t>
+                      </a:r>
+                      <a:r>
+                        <a:rPr lang="en-US" sz="1100" b="1" dirty="0" err="1">
+                          <a:solidFill>
+                            <a:srgbClr val="22543D"/>
+                          </a:solidFill>
+                          <a:latin typeface="Calibri" pitchFamily="34" charset="0"/>
+                          <a:ea typeface="Calibri" pitchFamily="34" charset="-122"/>
+                          <a:cs typeface="Calibri" pitchFamily="34" charset="-120"/>
+                        </a:rPr>
+                        <a:t>validés</a:t>
+                      </a:r>
+                      <a:r>
+                        <a:rPr lang="en-US" sz="1100" b="1" dirty="0">
+                          <a:solidFill>
+                            <a:srgbClr val="22543D"/>
+                          </a:solidFill>
+                          <a:latin typeface="Calibri" pitchFamily="34" charset="0"/>
+                          <a:ea typeface="Calibri" pitchFamily="34" charset="-122"/>
+                          <a:cs typeface="Calibri" pitchFamily="34" charset="-120"/>
+                        </a:rPr>
+                        <a:t> et </a:t>
+                      </a:r>
+                      <a:r>
+                        <a:rPr lang="en-US" sz="1100" b="1" dirty="0" err="1">
+                          <a:solidFill>
+                            <a:srgbClr val="22543D"/>
+                          </a:solidFill>
+                          <a:latin typeface="Calibri" pitchFamily="34" charset="0"/>
+                          <a:ea typeface="Calibri" pitchFamily="34" charset="-122"/>
+                          <a:cs typeface="Calibri" pitchFamily="34" charset="-120"/>
+                        </a:rPr>
+                        <a:t>pointés</a:t>
+                      </a:r>
+                      <a:r>
+                        <a:rPr lang="en-US" sz="1100" b="1" dirty="0">
+                          <a:solidFill>
+                            <a:srgbClr val="22543D"/>
+                          </a:solidFill>
+                          <a:latin typeface="Calibri" pitchFamily="34" charset="0"/>
+                          <a:ea typeface="Calibri" pitchFamily="34" charset="-122"/>
+                          <a:cs typeface="Calibri" pitchFamily="34" charset="-120"/>
+                        </a:rPr>
+                        <a:t> dans un lot </a:t>
+                      </a:r>
+                      <a:r>
+                        <a:rPr lang="en-US" sz="1100" b="1" dirty="0" err="1">
+                          <a:solidFill>
+                            <a:srgbClr val="22543D"/>
+                          </a:solidFill>
+                          <a:latin typeface="Calibri" pitchFamily="34" charset="0"/>
+                          <a:ea typeface="Calibri" pitchFamily="34" charset="-122"/>
+                          <a:cs typeface="Calibri" pitchFamily="34" charset="-120"/>
+                        </a:rPr>
+                        <a:t>isolé</a:t>
+                      </a:r>
+                      <a:r>
+                        <a:rPr lang="en-US" sz="1100" b="1" dirty="0">
+                          <a:solidFill>
+                            <a:srgbClr val="22543D"/>
+                          </a:solidFill>
+                          <a:latin typeface="Calibri" pitchFamily="34" charset="0"/>
+                          <a:ea typeface="Calibri" pitchFamily="34" charset="-122"/>
+                          <a:cs typeface="Calibri" pitchFamily="34" charset="-120"/>
+                        </a:rPr>
+                        <a:t>.</a:t>
+                      </a:r>
+                      <a:endParaRPr lang="en-US" sz="1100" dirty="0">
+                        <a:latin typeface="Calibri" charset="0"/>
+                        <a:ea typeface="Calibri" charset="0"/>
+                        <a:cs typeface="Calibri" charset="0"/>
+                      </a:endParaRPr>
+                    </a:p>
+                  </a:txBody>
+                  <a:tcPr marL="73152" marR="73152" marT="0" marB="0" anchor="ctr">
+                    <a:lnL w="6350" cap="flat" cmpd="sng" algn="ctr">
+                      <a:solidFill>
+                        <a:srgbClr val="D5DBE5"/>
+                      </a:solidFill>
+                      <a:prstDash val="solid"/>
+                      <a:round/>
+                      <a:headEnd type="none" w="med" len="med"/>
+                      <a:tailEnd type="none" w="med" len="med"/>
+                    </a:lnL>
+                    <a:lnR w="6350" cap="flat" cmpd="sng" algn="ctr">
+                      <a:solidFill>
+                        <a:srgbClr val="D5DBE5"/>
+                      </a:solidFill>
+                      <a:prstDash val="solid"/>
+                      <a:round/>
+                      <a:headEnd type="none" w="med" len="med"/>
+                      <a:tailEnd type="none" w="med" len="med"/>
+                    </a:lnR>
+                    <a:lnT w="6350" cap="flat" cmpd="sng" algn="ctr">
+                      <a:solidFill>
+                        <a:srgbClr val="D5DBE5"/>
+                      </a:solidFill>
+                      <a:prstDash val="solid"/>
+                      <a:round/>
+                      <a:headEnd type="none" w="med" len="med"/>
+                      <a:tailEnd type="none" w="med" len="med"/>
+                    </a:lnT>
+                    <a:lnB w="6350" cap="flat" cmpd="sng" algn="ctr">
+                      <a:solidFill>
+                        <a:srgbClr val="D5DBE5"/>
+                      </a:solidFill>
+                      <a:prstDash val="solid"/>
+                      <a:round/>
+                      <a:headEnd type="none" w="med" len="med"/>
+                      <a:tailEnd type="none" w="med" len="med"/>
+                    </a:lnB>
+                    <a:solidFill>
+                      <a:srgbClr val="FFFFFF"/>
+                    </a:solidFill>
+                  </a:tcPr>
+                </a:tc>
+                <a:extLst>
+                  <a:ext uri="{0D108BD9-81ED-4DB2-BD59-A6C34878D82A}">
+                    <a16:rowId xmlns:a16="http://schemas.microsoft.com/office/drawing/2014/main" val="1256387150"/>
+                  </a:ext>
+                </a:extLst>
+              </a:tr>
             </a:tbl>
           </a:graphicData>
         </a:graphic>
@@ -8723,7 +9379,7 @@
         </p:nvSpPr>
         <p:spPr>
           <a:xfrm>
-            <a:off x="457200" y="3108960"/>
+            <a:off x="457200" y="3349345"/>
             <a:ext cx="3017520" cy="228600"/>
           </a:xfrm>
           <a:prstGeom prst="rect">
@@ -8748,7 +9404,29 @@
                 <a:ea typeface="Calibri" pitchFamily="34" charset="-122"/>
                 <a:cs typeface="Calibri" pitchFamily="34" charset="-120"/>
               </a:rPr>
-              <a:t>Gantt : 15 tâches au vert en 14,18 s</a:t>
+              <a:t>Gantt : 14 tâches au vert </a:t>
+            </a:r>
+            <a:r>
+              <a:rPr lang="en-US" sz="1100" b="1" dirty="0" err="1">
+                <a:solidFill>
+                  <a:schemeClr val="accent3"/>
+                </a:solidFill>
+                <a:latin typeface="Calibri" pitchFamily="34" charset="0"/>
+                <a:ea typeface="Calibri" pitchFamily="34" charset="-122"/>
+                <a:cs typeface="Calibri" pitchFamily="34" charset="-120"/>
+              </a:rPr>
+              <a:t>en</a:t>
+            </a:r>
+            <a:r>
+              <a:rPr lang="en-US" sz="1100" b="1" dirty="0">
+                <a:solidFill>
+                  <a:schemeClr val="accent3"/>
+                </a:solidFill>
+                <a:latin typeface="Calibri" pitchFamily="34" charset="0"/>
+                <a:ea typeface="Calibri" pitchFamily="34" charset="-122"/>
+                <a:cs typeface="Calibri" pitchFamily="34" charset="-120"/>
+              </a:rPr>
+              <a:t> 18,94 s</a:t>
             </a:r>
             <a:endParaRPr lang="en-US" sz="1100" dirty="0"/>
           </a:p>
@@ -8762,8 +9440,8 @@
         </p:nvSpPr>
         <p:spPr>
           <a:xfrm>
-            <a:off x="3749040" y="3108960"/>
-            <a:ext cx="4572000" cy="228600"/>
+            <a:off x="4374035" y="3349345"/>
+            <a:ext cx="4130826" cy="228600"/>
           </a:xfrm>
           <a:prstGeom prst="rect">
             <a:avLst/>
@@ -8793,54 +9471,6 @@
           </a:p>
         </p:txBody>
       </p:sp>
-      <p:pic>
-        <p:nvPicPr>
-          <p:cNvPr id="6" name="Capture Gantt" descr="Diagramme de Gantt Kestra, 15 tâches réussies"/>
-          <p:cNvPicPr>
-            <a:picLocks noChangeAspect="1"/>
-          </p:cNvPicPr>
-          <p:nvPr/>
-        </p:nvPicPr>
-        <p:blipFill>
-          <a:blip r:embed="rId3"/>
-          <a:stretch>
-            <a:fillRect/>
-          </a:stretch>
-        </p:blipFill>
-        <p:spPr>
-          <a:xfrm>
-            <a:off x="457200" y="3364992"/>
-            <a:ext cx="3017520" cy="1423209"/>
-          </a:xfrm>
-          <a:prstGeom prst="rect">
-            <a:avLst/>
-          </a:prstGeom>
-        </p:spPr>
-      </p:pic>
-      <p:pic>
-        <p:nvPicPr>
-          <p:cNvPr id="7" name="Capture logs" descr="Journaux Kestra des 5 tests validés"/>
-          <p:cNvPicPr>
-            <a:picLocks noChangeAspect="1"/>
-          </p:cNvPicPr>
-          <p:nvPr/>
-        </p:nvPicPr>
-        <p:blipFill>
-          <a:blip r:embed="rId4"/>
-          <a:stretch>
-            <a:fillRect/>
-          </a:stretch>
-        </p:blipFill>
-        <p:spPr>
-          <a:xfrm>
-            <a:off x="3749040" y="3364992"/>
-            <a:ext cx="4480560" cy="1385042"/>
-          </a:xfrm>
-          <a:prstGeom prst="rect">
-            <a:avLst/>
-          </a:prstGeom>
-        </p:spPr>
-      </p:pic>
       <p:sp>
         <p:nvSpPr>
           <p:cNvPr id="25" name="Slide Number Placeholder 0"/>
@@ -8889,6 +9519,68 @@
           </a:p>
         </p:txBody>
       </p:sp>
+      <p:pic>
+        <p:nvPicPr>
+          <p:cNvPr id="9" name="Image 8" descr="The image displays a project management dashboard, showcasing a Gantt chart with various tasks, executions, and timelines, including details like duration, success, and dependencies.&#10;&#10;Le contenu généré par l’IA peut être incorrect.">
+            <a:extLst>
+              <a:ext uri="{FF2B5EF4-FFF2-40B4-BE49-F238E27FC236}">
+                <a16:creationId xmlns:a16="http://schemas.microsoft.com/office/drawing/2014/main" id="{D2152B8B-9864-E4E7-8290-CBA355F864B9}"/>
+              </a:ext>
+            </a:extLst>
+          </p:cNvPr>
+          <p:cNvPicPr>
+            <a:picLocks noChangeAspect="1"/>
+          </p:cNvPicPr>
+          <p:nvPr/>
+        </p:nvPicPr>
+        <p:blipFill>
+          <a:blip r:embed="rId3"/>
+          <a:srcRect l="10000" t="14219" r="1289" b="8702"/>
+          <a:stretch>
+            <a:fillRect/>
+          </a:stretch>
+        </p:blipFill>
+        <p:spPr>
+          <a:xfrm>
+            <a:off x="482655" y="3512941"/>
+            <a:ext cx="3589726" cy="1584340"/>
+          </a:xfrm>
+          <a:prstGeom prst="rect">
+            <a:avLst/>
+          </a:prstGeom>
+        </p:spPr>
+      </p:pic>
+      <p:pic>
+        <p:nvPicPr>
+          <p:cNvPr id="11" name="Image 10" descr="The image shows a detailed log from a data processing pipeline, indicating various stages such as ingestion, cleaning, deduplication, and testing, with different metrics for lines processed and unique values validated.&#10;&#10;Le contenu généré par l’IA peut être incorrect.">
+            <a:extLst>
+              <a:ext uri="{FF2B5EF4-FFF2-40B4-BE49-F238E27FC236}">
+                <a16:creationId xmlns:a16="http://schemas.microsoft.com/office/drawing/2014/main" id="{1C42E5C3-40D3-9DEF-4E21-EDCFDE8F4649}"/>
+              </a:ext>
+            </a:extLst>
+          </p:cNvPr>
+          <p:cNvPicPr>
+            <a:picLocks noChangeAspect="1"/>
+          </p:cNvPicPr>
+          <p:nvPr/>
+        </p:nvPicPr>
+        <p:blipFill>
+          <a:blip r:embed="rId4"/>
+          <a:srcRect l="10802" t="14805" r="21920" b="26965"/>
+          <a:stretch>
+            <a:fillRect/>
+          </a:stretch>
+        </p:blipFill>
+        <p:spPr>
+          <a:xfrm>
+            <a:off x="4374035" y="3514407"/>
+            <a:ext cx="3190974" cy="1584837"/>
+          </a:xfrm>
+          <a:prstGeom prst="rect">
+            <a:avLst/>
+          </a:prstGeom>
+        </p:spPr>
+      </p:pic>
     </p:spTree>
   </p:cSld>
   <p:clrMapOvr>
@@ -9023,7 +9715,7 @@
         </p:nvSpPr>
         <p:spPr>
           <a:xfrm>
-            <a:off x="457200" y="3468661"/>
+            <a:off x="457200" y="3562923"/>
             <a:ext cx="5029200" cy="1149059"/>
           </a:xfrm>
           <a:prstGeom prst="roundRect">
@@ -9059,7 +9751,7 @@
         </p:nvSpPr>
         <p:spPr>
           <a:xfrm>
-            <a:off x="640080" y="3651541"/>
+            <a:off x="640080" y="3745803"/>
             <a:ext cx="457200" cy="457200"/>
           </a:xfrm>
           <a:prstGeom prst="ellipse">
@@ -9094,7 +9786,7 @@
         </p:blipFill>
         <p:spPr>
           <a:xfrm>
-            <a:off x="754380" y="3765841"/>
+            <a:off x="754380" y="3860103"/>
             <a:ext cx="228600" cy="228600"/>
           </a:xfrm>
           <a:prstGeom prst="rect">
@@ -9110,7 +9802,7 @@
         </p:nvSpPr>
         <p:spPr>
           <a:xfrm>
-            <a:off x="1280160" y="3560101"/>
+            <a:off x="1280160" y="3654363"/>
             <a:ext cx="4114800" cy="966179"/>
           </a:xfrm>
           <a:prstGeom prst="rect">
@@ -9290,7 +9982,7 @@
           <a:p>
             <a:r>
               <a:rPr lang="fr-FR" sz="1100" dirty="0"/>
-              <a:t>Le contrôle détecte une anomalie (ici : un prix négatif ou nul) et donne l'alerte.</a:t>
+              <a:t>Le contrôle détecte une anomalie (ici : un prix négatif ou nul) et bloque immédiatement l'exécution.</a:t>
             </a:r>
             <a:endParaRPr lang="en-US" sz="1100" dirty="0"/>
           </a:p>
@@ -9298,7 +9990,61 @@
       </p:sp>
       <p:sp>
         <p:nvSpPr>
-          <p:cNvPr id="14" name="2. Arrêt franc"/>
+          <p:cNvPr id="25" name="Slide Number Placeholder 0"/>
+          <p:cNvSpPr>
+            <a:spLocks noGrp="1"/>
+          </p:cNvSpPr>
+          <p:nvPr>
+            <p:ph type="sldNum" sz="quarter" idx="4294967295"/>
+          </p:nvPr>
+        </p:nvSpPr>
+        <p:spPr>
+          <a:xfrm>
+            <a:off x="8412480" y="4828032"/>
+            <a:ext cx="457200" cy="228600"/>
+          </a:xfrm>
+          <a:prstGeom prst="rect">
+            <a:avLst/>
+          </a:prstGeom>
+          <a:extLst>
+            <a:ext uri="{C572A759-6A51-4108-AA02-DFA0A04FC94B}">
+              <ma14:wrappingTextBoxFlag xmlns="" xmlns:ma14="http://schemas.microsoft.com/office/mac/drawingml/2011/main" val="0"/>
+            </a:ext>
+          </a:extLst>
+        </p:spPr>
+        <p:txBody>
+          <a:bodyPr/>
+          <a:lstStyle>
+            <a:lvl1pPr>
+              <a:defRPr sz="1000">
+                <a:solidFill>
+                  <a:srgbClr val="5A6B82"/>
+                </a:solidFill>
+                <a:latin typeface="Calibri"/>
+                <a:ea typeface="Calibri"/>
+                <a:cs typeface="Calibri"/>
+              </a:defRPr>
+            </a:lvl1pPr>
+          </a:lstStyle>
+          <a:p>
+            <a:pPr algn="l"/>
+            <a:fld id="{F7021451-1387-4CA6-816F-3879F97B5CBC}" type="slidenum">
+              <a:rPr lang="en-US" b="0"/>
+              <a:t>8</a:t>
+            </a:fld>
+            <a:endParaRPr lang="en-US"/>
+          </a:p>
+        </p:txBody>
+      </p:sp>
+      <p:sp>
+        <p:nvSpPr>
+          <p:cNvPr id="26" name="2. Arrêt franc">
+            <a:extLst>
+              <a:ext uri="{FF2B5EF4-FFF2-40B4-BE49-F238E27FC236}">
+                <a16:creationId xmlns:a16="http://schemas.microsoft.com/office/drawing/2014/main" id="{F4B8C012-787C-6F7D-0649-16AEBA4F11A1}"/>
+              </a:ext>
+            </a:extLst>
+          </p:cNvPr>
           <p:cNvSpPr/>
           <p:nvPr/>
         </p:nvSpPr>
@@ -9334,7 +10080,13 @@
       </p:sp>
       <p:sp>
         <p:nvSpPr>
-          <p:cNvPr id="15" name="2. Arrêt franc cercle"/>
+          <p:cNvPr id="28" name="2. Arrêt franc cercle">
+            <a:extLst>
+              <a:ext uri="{FF2B5EF4-FFF2-40B4-BE49-F238E27FC236}">
+                <a16:creationId xmlns:a16="http://schemas.microsoft.com/office/drawing/2014/main" id="{F11D4AB8-A2CC-E13D-B03D-53B7F19E197F}"/>
+              </a:ext>
+            </a:extLst>
+          </p:cNvPr>
           <p:cNvSpPr/>
           <p:nvPr/>
         </p:nvSpPr>
@@ -9361,7 +10113,13 @@
       </p:sp>
       <p:pic>
         <p:nvPicPr>
-          <p:cNvPr id="16" name="2. Arrêt franc" descr="2. Arrêt franc"/>
+          <p:cNvPr id="30" name="2. Arrêt franc" descr="2. Arrêt franc">
+            <a:extLst>
+              <a:ext uri="{FF2B5EF4-FFF2-40B4-BE49-F238E27FC236}">
+                <a16:creationId xmlns:a16="http://schemas.microsoft.com/office/drawing/2014/main" id="{C15164BD-F19A-6842-C66F-A8E8818FFA0C}"/>
+              </a:ext>
+            </a:extLst>
+          </p:cNvPr>
           <p:cNvPicPr>
             <a:picLocks noChangeAspect="1"/>
           </p:cNvPicPr>
@@ -9385,7 +10143,13 @@
       </p:pic>
       <p:sp>
         <p:nvSpPr>
-          <p:cNvPr id="17" name="Text 11"/>
+          <p:cNvPr id="32" name="Text 11">
+            <a:extLst>
+              <a:ext uri="{FF2B5EF4-FFF2-40B4-BE49-F238E27FC236}">
+                <a16:creationId xmlns:a16="http://schemas.microsoft.com/office/drawing/2014/main" id="{25B45044-EC7C-3A58-DC03-52C48136DDC3}"/>
+              </a:ext>
+            </a:extLst>
+          </p:cNvPr>
           <p:cNvSpPr txBox="1"/>
           <p:nvPr/>
         </p:nvSpPr>
@@ -9424,7 +10188,13 @@
       </p:sp>
       <p:sp>
         <p:nvSpPr>
-          <p:cNvPr id="18" name="Text 12"/>
+          <p:cNvPr id="34" name="Text 12">
+            <a:extLst>
+              <a:ext uri="{FF2B5EF4-FFF2-40B4-BE49-F238E27FC236}">
+                <a16:creationId xmlns:a16="http://schemas.microsoft.com/office/drawing/2014/main" id="{13AC3458-777B-2FA7-141D-66B5FC57725D}"/>
+              </a:ext>
+            </a:extLst>
+          </p:cNvPr>
           <p:cNvSpPr txBox="1"/>
           <p:nvPr/>
         </p:nvSpPr>
@@ -9443,110 +10213,17 @@
           <a:bodyPr wrap="square" lIns="0" tIns="0" rIns="0" bIns="0" rtlCol="0" anchor="t"/>
           <a:lstStyle/>
           <a:p>
-            <a:pPr marL="0" indent="0">
-              <a:buNone/>
-            </a:pPr>
-            <a:r>
-              <a:rPr lang="en-US" sz="1100" dirty="0">
-                <a:solidFill>
-                  <a:schemeClr val="tx1"/>
-                </a:solidFill>
-                <a:latin typeface="Calibri" pitchFamily="34" charset="0"/>
-                <a:ea typeface="Calibri" pitchFamily="34" charset="-122"/>
-                <a:cs typeface="Calibri" pitchFamily="34" charset="-120"/>
-              </a:rPr>
-              <a:t>Les tâches aval (calculs, exports Excel/CSV) ne sont pas </a:t>
-            </a:r>
-            <a:r>
-              <a:rPr lang="en-US" sz="1100" dirty="0" err="1">
-                <a:solidFill>
-                  <a:schemeClr val="tx1"/>
-                </a:solidFill>
-                <a:latin typeface="Calibri" pitchFamily="34" charset="0"/>
-                <a:ea typeface="Calibri" pitchFamily="34" charset="-122"/>
-                <a:cs typeface="Calibri" pitchFamily="34" charset="-120"/>
-              </a:rPr>
-              <a:t>exécutées</a:t>
-            </a:r>
-            <a:r>
-              <a:rPr lang="en-US" sz="1100" dirty="0">
-                <a:solidFill>
-                  <a:schemeClr val="tx1"/>
-                </a:solidFill>
-                <a:latin typeface="Calibri" pitchFamily="34" charset="0"/>
-                <a:ea typeface="Calibri" pitchFamily="34" charset="-122"/>
-                <a:cs typeface="Calibri" pitchFamily="34" charset="-120"/>
-              </a:rPr>
-              <a:t>.</a:t>
-            </a:r>
-          </a:p>
-          <a:p>
-            <a:pPr marL="0" indent="0">
-              <a:buNone/>
-            </a:pPr>
-            <a:r>
-              <a:rPr lang="en-US" sz="1100" dirty="0">
-                <a:latin typeface="Calibri" pitchFamily="34" charset="0"/>
-                <a:ea typeface="Calibri" pitchFamily="34" charset="-122"/>
-                <a:cs typeface="Calibri" pitchFamily="34" charset="-120"/>
-              </a:rPr>
-              <a:t>Les </a:t>
-            </a:r>
-            <a:r>
-              <a:rPr lang="en-US" sz="1100" dirty="0" err="1">
-                <a:latin typeface="Calibri" pitchFamily="34" charset="0"/>
-                <a:ea typeface="Calibri" pitchFamily="34" charset="-122"/>
-                <a:cs typeface="Calibri" pitchFamily="34" charset="-120"/>
-              </a:rPr>
-              <a:t>anciens</a:t>
-            </a:r>
-            <a:r>
-              <a:rPr lang="en-US" sz="1100" dirty="0">
-                <a:latin typeface="Calibri" pitchFamily="34" charset="0"/>
-                <a:ea typeface="Calibri" pitchFamily="34" charset="-122"/>
-                <a:cs typeface="Calibri" pitchFamily="34" charset="-120"/>
-              </a:rPr>
-              <a:t> </a:t>
-            </a:r>
-            <a:r>
-              <a:rPr lang="en-US" sz="1100" dirty="0" err="1">
-                <a:latin typeface="Calibri" pitchFamily="34" charset="0"/>
-                <a:ea typeface="Calibri" pitchFamily="34" charset="-122"/>
-                <a:cs typeface="Calibri" pitchFamily="34" charset="-120"/>
-              </a:rPr>
-              <a:t>fichiers</a:t>
-            </a:r>
-            <a:r>
-              <a:rPr lang="en-US" sz="1100" dirty="0">
-                <a:latin typeface="Calibri" pitchFamily="34" charset="0"/>
-                <a:ea typeface="Calibri" pitchFamily="34" charset="-122"/>
-                <a:cs typeface="Calibri" pitchFamily="34" charset="-120"/>
-              </a:rPr>
-              <a:t> de production </a:t>
-            </a:r>
-            <a:r>
-              <a:rPr lang="en-US" sz="1100" dirty="0" err="1">
-                <a:latin typeface="Calibri" pitchFamily="34" charset="0"/>
-                <a:ea typeface="Calibri" pitchFamily="34" charset="-122"/>
-                <a:cs typeface="Calibri" pitchFamily="34" charset="-120"/>
-              </a:rPr>
-              <a:t>sont</a:t>
-            </a:r>
-            <a:r>
-              <a:rPr lang="en-US" sz="1100" dirty="0">
-                <a:latin typeface="Calibri" pitchFamily="34" charset="0"/>
-                <a:ea typeface="Calibri" pitchFamily="34" charset="-122"/>
-                <a:cs typeface="Calibri" pitchFamily="34" charset="-120"/>
-              </a:rPr>
-              <a:t> </a:t>
-            </a:r>
-            <a:r>
-              <a:rPr lang="en-US" sz="1100" dirty="0" err="1">
-                <a:latin typeface="Calibri" pitchFamily="34" charset="0"/>
-                <a:ea typeface="Calibri" pitchFamily="34" charset="-122"/>
-                <a:cs typeface="Calibri" pitchFamily="34" charset="-120"/>
-              </a:rPr>
-              <a:t>préservés</a:t>
+            <a:r>
+              <a:rPr lang="fr-FR" sz="1100" dirty="0"/>
+              <a:t>Les tâches aval ne sont pas exécutées et le </a:t>
+            </a:r>
+            <a:r>
+              <a:rPr lang="fr-FR" sz="1100" dirty="0" err="1"/>
+              <a:t>staging</a:t>
+            </a:r>
+            <a:r>
+              <a:rPr lang="fr-FR" sz="1100" dirty="0"/>
+              <a:t> est purgé. Le dernier lot pointé par LAST_VALID_LOT.txt reste intact.</a:t>
             </a:r>
             <a:endParaRPr lang="en-US" sz="1100" dirty="0"/>
           </a:p>
@@ -9554,14 +10231,20 @@
       </p:sp>
       <p:sp>
         <p:nvSpPr>
-          <p:cNvPr id="19" name="3. Alerte automatique"/>
+          <p:cNvPr id="36" name="3. Alerte automatique">
+            <a:extLst>
+              <a:ext uri="{FF2B5EF4-FFF2-40B4-BE49-F238E27FC236}">
+                <a16:creationId xmlns:a16="http://schemas.microsoft.com/office/drawing/2014/main" id="{852A43E0-DFC7-747C-CD45-45EE4DAA14A6}"/>
+              </a:ext>
+            </a:extLst>
+          </p:cNvPr>
           <p:cNvSpPr/>
           <p:nvPr/>
         </p:nvSpPr>
         <p:spPr>
           <a:xfrm>
             <a:off x="5715000" y="3546986"/>
-            <a:ext cx="2971800" cy="1097280"/>
+            <a:ext cx="2971800" cy="1188720"/>
           </a:xfrm>
           <a:prstGeom prst="roundRect">
             <a:avLst>
@@ -9590,7 +10273,13 @@
       </p:sp>
       <p:sp>
         <p:nvSpPr>
-          <p:cNvPr id="20" name="3. Alerte automatique cercle"/>
+          <p:cNvPr id="38" name="3. Alerte automatique cercle">
+            <a:extLst>
+              <a:ext uri="{FF2B5EF4-FFF2-40B4-BE49-F238E27FC236}">
+                <a16:creationId xmlns:a16="http://schemas.microsoft.com/office/drawing/2014/main" id="{7CBFE5AB-EC65-E989-DF45-D8EFCAD09939}"/>
+              </a:ext>
+            </a:extLst>
+          </p:cNvPr>
           <p:cNvSpPr/>
           <p:nvPr/>
         </p:nvSpPr>
@@ -9617,7 +10306,13 @@
       </p:sp>
       <p:pic>
         <p:nvPicPr>
-          <p:cNvPr id="21" name="3. Alerte automatique" descr="3. Alerte automatique"/>
+          <p:cNvPr id="40" name="3. Alerte automatique" descr="3. Alerte automatique">
+            <a:extLst>
+              <a:ext uri="{FF2B5EF4-FFF2-40B4-BE49-F238E27FC236}">
+                <a16:creationId xmlns:a16="http://schemas.microsoft.com/office/drawing/2014/main" id="{970A4B21-D01C-091D-F4F1-6B5E7A632E12}"/>
+              </a:ext>
+            </a:extLst>
+          </p:cNvPr>
           <p:cNvPicPr>
             <a:picLocks noChangeAspect="1"/>
           </p:cNvPicPr>
@@ -9641,7 +10336,13 @@
       </p:pic>
       <p:sp>
         <p:nvSpPr>
-          <p:cNvPr id="22" name="Text 15"/>
+          <p:cNvPr id="42" name="Text 15">
+            <a:extLst>
+              <a:ext uri="{FF2B5EF4-FFF2-40B4-BE49-F238E27FC236}">
+                <a16:creationId xmlns:a16="http://schemas.microsoft.com/office/drawing/2014/main" id="{7AEB2406-A93D-670B-D2AE-0C2279885099}"/>
+              </a:ext>
+            </a:extLst>
+          </p:cNvPr>
           <p:cNvSpPr txBox="1"/>
           <p:nvPr/>
         </p:nvSpPr>
@@ -9680,7 +10381,13 @@
       </p:sp>
       <p:sp>
         <p:nvSpPr>
-          <p:cNvPr id="23" name="Text 16"/>
+          <p:cNvPr id="44" name="Text 16">
+            <a:extLst>
+              <a:ext uri="{FF2B5EF4-FFF2-40B4-BE49-F238E27FC236}">
+                <a16:creationId xmlns:a16="http://schemas.microsoft.com/office/drawing/2014/main" id="{FE75D5D8-DE83-AA0A-3CD3-A319D694A266}"/>
+              </a:ext>
+            </a:extLst>
+          </p:cNvPr>
           <p:cNvSpPr txBox="1"/>
           <p:nvPr/>
         </p:nvSpPr>
@@ -9701,57 +10408,9 @@
           <a:p>
             <a:r>
               <a:rPr lang="fr-FR" sz="1100" dirty="0"/>
-              <a:t>Le système de surveillance envoie immédiatement un message d'alerte à l'équipe Data.</a:t>
+              <a:t>En cas d'anomalie, l'alerte reste une ligne tracée dans les logs Kestra, sans notification envoyée à l'équipe.</a:t>
             </a:r>
             <a:endParaRPr lang="en-US" sz="1100" dirty="0"/>
-          </a:p>
-        </p:txBody>
-      </p:sp>
-      <p:sp>
-        <p:nvSpPr>
-          <p:cNvPr id="25" name="Slide Number Placeholder 0"/>
-          <p:cNvSpPr>
-            <a:spLocks noGrp="1"/>
-          </p:cNvSpPr>
-          <p:nvPr>
-            <p:ph type="sldNum" sz="quarter" idx="4294967295"/>
-          </p:nvPr>
-        </p:nvSpPr>
-        <p:spPr>
-          <a:xfrm>
-            <a:off x="8412480" y="4828032"/>
-            <a:ext cx="457200" cy="228600"/>
-          </a:xfrm>
-          <a:prstGeom prst="rect">
-            <a:avLst/>
-          </a:prstGeom>
-          <a:extLst>
-            <a:ext uri="{C572A759-6A51-4108-AA02-DFA0A04FC94B}">
-              <ma14:wrappingTextBoxFlag xmlns="" xmlns:ma14="http://schemas.microsoft.com/office/mac/drawingml/2011/main" val="0"/>
-            </a:ext>
-          </a:extLst>
-        </p:spPr>
-        <p:txBody>
-          <a:bodyPr/>
-          <a:lstStyle>
-            <a:lvl1pPr>
-              <a:defRPr sz="1000">
-                <a:solidFill>
-                  <a:srgbClr val="5A6B82"/>
-                </a:solidFill>
-                <a:latin typeface="Calibri"/>
-                <a:ea typeface="Calibri"/>
-                <a:cs typeface="Calibri"/>
-              </a:defRPr>
-            </a:lvl1pPr>
-          </a:lstStyle>
-          <a:p>
-            <a:pPr algn="l"/>
-            <a:fld id="{F7021451-1387-4CA6-816F-3879F97B5CBC}" type="slidenum">
-              <a:rPr lang="en-US" b="0"/>
-              <a:t>8</a:t>
-            </a:fld>
-            <a:endParaRPr lang="en-US"/>
           </a:p>
         </p:txBody>
       </p:sp>
@@ -10052,26 +10711,7 @@
                 <a:ea typeface="Calibri" pitchFamily="34" charset="-122"/>
                 <a:cs typeface="Calibri" pitchFamily="34" charset="-120"/>
               </a:rPr>
-              <a:t>Retry automatique : 3 tentatives espacées de </a:t>
-            </a:r>
-            <a:r>
-              <a:rPr lang="en-US" sz="1200" dirty="0">
-                <a:latin typeface="Calibri" pitchFamily="34" charset="0"/>
-                <a:ea typeface="Calibri" pitchFamily="34" charset="-122"/>
-                <a:cs typeface="Calibri" pitchFamily="34" charset="-120"/>
-              </a:rPr>
-              <a:t>10</a:t>
-            </a:r>
-            <a:r>
-              <a:rPr lang="en-US" sz="1200" dirty="0">
-                <a:solidFill>
-                  <a:schemeClr val="tx1"/>
-                </a:solidFill>
-                <a:latin typeface="Calibri" pitchFamily="34" charset="0"/>
-                <a:ea typeface="Calibri" pitchFamily="34" charset="-122"/>
-                <a:cs typeface="Calibri" pitchFamily="34" charset="-120"/>
-              </a:rPr>
-              <a:t> secondes avant échec.</a:t>
+              <a:t>Retry automatique : 3 tentatives espacées de 10 secondes avant échec.</a:t>
             </a:r>
             <a:endParaRPr lang="en-US" sz="1300" dirty="0"/>
           </a:p>
@@ -10335,19 +10975,9 @@
             <a:endParaRPr lang="en-US" sz="1300" dirty="0"/>
           </a:p>
           <a:p>
-            <a:pPr marL="0" indent="0">
-              <a:buNone/>
-            </a:pPr>
-            <a:r>
-              <a:rPr lang="en-US" sz="1200" dirty="0">
-                <a:solidFill>
-                  <a:schemeClr val="tx1"/>
-                </a:solidFill>
-                <a:latin typeface="Calibri" pitchFamily="34" charset="0"/>
-                <a:ea typeface="Calibri" pitchFamily="34" charset="-122"/>
-                <a:cs typeface="Calibri" pitchFamily="34" charset="-120"/>
-              </a:rPr>
-              <a:t>Exécution locale isolée ; base bottleneck.duckdb sur volume Docker monté.</a:t>
+            <a:r>
+              <a:rPr lang="fr-FR" sz="1200" dirty="0"/>
+              <a:t>Création des fichiers dans un espace temporaire, puis validation finale dans un dossier dédié pointé par LAST_VALID_LOT.txt.</a:t>
             </a:r>
             <a:endParaRPr lang="en-US" sz="1300" dirty="0"/>
           </a:p>
@@ -10713,19 +11343,9 @@
             <a:endParaRPr lang="en-US" sz="1300" dirty="0"/>
           </a:p>
           <a:p>
-            <a:pPr marL="0" indent="0">
-              <a:buNone/>
-            </a:pPr>
-            <a:r>
-              <a:rPr lang="en-US" sz="1200" dirty="0">
-                <a:solidFill>
-                  <a:schemeClr val="tx1"/>
-                </a:solidFill>
-                <a:latin typeface="Calibri" pitchFamily="34" charset="0"/>
-                <a:ea typeface="Calibri" pitchFamily="34" charset="-122"/>
-                <a:cs typeface="Calibri" pitchFamily="34" charset="-120"/>
-              </a:rPr>
-              <a:t>Plages de tolérance à la place des seuils fixes (ex. 714) quand le catalogue grandit.</a:t>
+            <a:r>
+              <a:rPr lang="fr-FR" sz="1200" dirty="0"/>
+              <a:t>Mode PRODUCTION_MENSUELLE déjà actif sur le trigger : contrôle d'invariants dynamiques sans seuils fixes lorsque le catalogue évolue.</a:t>
             </a:r>
             <a:endParaRPr lang="en-US" sz="1300" dirty="0"/>
           </a:p>

</xml_diff>